<commit_message>
Sincroniza apresentaÃ§Ã£o e Parquets finais
</commit_message>
<xml_diff>
--- a/apresentacao/Apresentacao_Tarefa4_Engenharia_Dados.pptx
+++ b/apresentacao/Apresentacao_Tarefa4_Engenharia_Dados.pptx
@@ -2108,32 +2108,16 @@
           <a:bodyPr wrap="square" lIns="635" tIns="635" rIns="635" bIns="635" rtlCol="0" anchor="ctr"/>
           <a:lstStyle/>
           <a:p>
-            <a:pPr marL="0" indent="0" algn="ctr">
-              <a:buNone/>
-            </a:pPr>
-            <a:r>
-              <a:rPr lang="en-US" sz="1400" b="1" dirty="0">
-                <a:solidFill>
-                  <a:srgbClr val="FFFFFF"/>
-                </a:solidFill>
-              </a:rPr>
+            <a:r>
+              <a:rPr sz="1800"/>
               <a:t>TRUSTED</a:t>
             </a:r>
-            <a:endParaRPr lang="en-US" sz="1400" dirty="0"/>
-          </a:p>
-          <a:p>
-            <a:pPr marL="0" indent="0" algn="ctr">
-              <a:buNone/>
-            </a:pPr>
-            <a:r>
-              <a:rPr lang="en-US" sz="1400" b="1" dirty="0">
-                <a:solidFill>
-                  <a:srgbClr val="FFFFFF"/>
-                </a:solidFill>
-              </a:rPr>
-              <a:t>918 • 1.474 • 39</a:t>
-            </a:r>
-            <a:endParaRPr lang="en-US" sz="1400" dirty="0"/>
+          </a:p>
+          <a:p>
+            <a:r>
+              <a:rPr sz="1800"/>
+              <a:t>918 • 1.459 • 39</a:t>
+            </a:r>
           </a:p>
         </p:txBody>
       </p:sp>
@@ -2252,32 +2236,16 @@
           <a:bodyPr wrap="square" lIns="635" tIns="635" rIns="635" bIns="635" rtlCol="0" anchor="ctr"/>
           <a:lstStyle/>
           <a:p>
-            <a:pPr marL="0" indent="0" algn="ctr">
-              <a:buNone/>
-            </a:pPr>
-            <a:r>
-              <a:rPr lang="en-US" sz="1300" b="1" dirty="0">
-                <a:solidFill>
-                  <a:srgbClr val="FFFFFF"/>
-                </a:solidFill>
-              </a:rPr>
-              <a:t>24/24 testes dbt</a:t>
-            </a:r>
-            <a:endParaRPr lang="en-US" sz="1300" dirty="0"/>
-          </a:p>
-          <a:p>
-            <a:pPr marL="0" indent="0" algn="ctr">
-              <a:buNone/>
-            </a:pPr>
-            <a:r>
-              <a:rPr lang="en-US" sz="1300" b="1" dirty="0">
-                <a:solidFill>
-                  <a:srgbClr val="FFFFFF"/>
-                </a:solidFill>
-              </a:rPr>
-              <a:t>28/28 build</a:t>
-            </a:r>
-            <a:endParaRPr lang="en-US" sz="1300" dirty="0"/>
+            <a:r>
+              <a:rPr sz="1800"/>
+              <a:t>29/29 testes dbt</a:t>
+            </a:r>
+          </a:p>
+          <a:p>
+            <a:r>
+              <a:rPr sz="1800"/>
+              <a:t>34/34 build</a:t>
+            </a:r>
           </a:p>
         </p:txBody>
       </p:sp>
@@ -2504,18 +2472,14 @@
           <a:bodyPr wrap="square" lIns="0" tIns="0" rIns="0" bIns="0" rtlCol="0" anchor="ctr"/>
           <a:lstStyle/>
           <a:p>
-            <a:pPr marL="0" indent="0" algn="ctr">
-              <a:buNone/>
-            </a:pPr>
-            <a:r>
-              <a:rPr lang="en-US" sz="2600" b="1" dirty="0">
-                <a:solidFill>
-                  <a:srgbClr val="2E7D32"/>
-                </a:solidFill>
-              </a:rPr>
-              <a:t>24/24</a:t>
-            </a:r>
-            <a:endParaRPr lang="en-US" sz="2600" dirty="0"/>
+            <a:r>
+              <a:rPr sz="2400">
+                <a:solidFill>
+                  <a:srgbClr val="000000"/>
+                </a:solidFill>
+              </a:rPr>
+              <a:t>29/29</a:t>
+            </a:r>
           </a:p>
         </p:txBody>
       </p:sp>
@@ -2578,18 +2542,14 @@
           <a:bodyPr wrap="square" lIns="0" tIns="0" rIns="0" bIns="0" rtlCol="0" anchor="ctr"/>
           <a:lstStyle/>
           <a:p>
-            <a:pPr marL="0" indent="0" algn="ctr">
-              <a:buNone/>
-            </a:pPr>
-            <a:r>
-              <a:rPr lang="en-US" sz="2600" b="1" dirty="0">
-                <a:solidFill>
-                  <a:srgbClr val="1F5EFF"/>
-                </a:solidFill>
-              </a:rPr>
-              <a:t>28/28</a:t>
-            </a:r>
-            <a:endParaRPr lang="en-US" sz="2600" dirty="0"/>
+            <a:r>
+              <a:rPr sz="2400">
+                <a:solidFill>
+                  <a:srgbClr val="000000"/>
+                </a:solidFill>
+              </a:rPr>
+              <a:t>34/34</a:t>
+            </a:r>
           </a:p>
         </p:txBody>
       </p:sp>
@@ -2652,18 +2612,14 @@
           <a:bodyPr wrap="square" lIns="0" tIns="0" rIns="0" bIns="0" rtlCol="0" anchor="ctr"/>
           <a:lstStyle/>
           <a:p>
-            <a:pPr marL="0" indent="0" algn="ctr">
-              <a:buNone/>
-            </a:pPr>
-            <a:r>
-              <a:rPr lang="en-US" sz="2600" b="1" dirty="0">
-                <a:solidFill>
-                  <a:srgbClr val="00A6A6"/>
-                </a:solidFill>
-              </a:rPr>
-              <a:t>4</a:t>
-            </a:r>
-            <a:endParaRPr lang="en-US" sz="2600" dirty="0"/>
+            <a:r>
+              <a:rPr sz="2400">
+                <a:solidFill>
+                  <a:srgbClr val="000000"/>
+                </a:solidFill>
+              </a:rPr>
+              <a:t>10</a:t>
+            </a:r>
           </a:p>
         </p:txBody>
       </p:sp>
@@ -2690,18 +2646,14 @@
           </a:bodyPr>
           <a:lstStyle/>
           <a:p>
-            <a:pPr marL="0" indent="0" algn="ctr">
-              <a:buNone/>
-            </a:pPr>
-            <a:r>
-              <a:rPr lang="en-US" sz="950" dirty="0">
-                <a:solidFill>
-                  <a:srgbClr val="667085"/>
-                </a:solidFill>
-              </a:rPr>
-              <a:t>modelos reconstruídos</a:t>
-            </a:r>
-            <a:endParaRPr lang="en-US" sz="950" dirty="0"/>
+            <a:r>
+              <a:rPr sz="1000">
+                <a:solidFill>
+                  <a:srgbClr val="000000"/>
+                </a:solidFill>
+              </a:rPr>
+              <a:t>modelos dbt</a:t>
+            </a:r>
           </a:p>
         </p:txBody>
       </p:sp>
@@ -2808,78 +2760,55 @@
           </a:bodyPr>
           <a:lstStyle/>
           <a:p>
-            <a:pPr marL="0" indent="0">
-              <a:buNone/>
-            </a:pPr>
-            <a:r>
-              <a:rPr lang="en-US" sz="1050" dirty="0">
-                <a:solidFill>
-                  <a:srgbClr val="F8FAFC"/>
-                </a:solidFill>
-                <a:latin typeface="Consolas" pitchFamily="34" charset="0"/>
-                <a:ea typeface="Consolas" pitchFamily="34" charset="-122"/>
-                <a:cs typeface="Consolas" pitchFamily="34" charset="-120"/>
+            <a:r>
+              <a:rPr sz="1000">
+                <a:solidFill>
+                  <a:srgbClr val="FFFFFF"/>
+                </a:solidFill>
               </a:rPr>
               <a:t>docker compose run --rm dbt dbt test</a:t>
             </a:r>
-            <a:endParaRPr lang="en-US" sz="1050" dirty="0"/>
-          </a:p>
-          <a:p>
-            <a:pPr marL="0" indent="0">
-              <a:buNone/>
-            </a:pPr>
-            <a:r>
-              <a:rPr lang="en-US" sz="1050" dirty="0">
-                <a:solidFill>
-                  <a:srgbClr val="F8FAFC"/>
-                </a:solidFill>
-                <a:latin typeface="Consolas" pitchFamily="34" charset="0"/>
-                <a:ea typeface="Consolas" pitchFamily="34" charset="-122"/>
-                <a:cs typeface="Consolas" pitchFamily="34" charset="-120"/>
-              </a:rPr>
-              <a:t>Done. PASS=24 WARN=0 ERROR=0 TOTAL=24</a:t>
-            </a:r>
-            <a:endParaRPr lang="en-US" sz="1050" dirty="0"/>
-          </a:p>
-          <a:p>
-            <a:pPr marL="0" indent="0">
-              <a:buNone/>
-            </a:pPr>
-            <a:endParaRPr lang="en-US" sz="1050" dirty="0"/>
-          </a:p>
-          <a:p>
-            <a:pPr marL="0" indent="0">
-              <a:buNone/>
-            </a:pPr>
-            <a:r>
-              <a:rPr lang="en-US" sz="1050" dirty="0">
-                <a:solidFill>
-                  <a:srgbClr val="F8FAFC"/>
-                </a:solidFill>
-                <a:latin typeface="Consolas" pitchFamily="34" charset="0"/>
-                <a:ea typeface="Consolas" pitchFamily="34" charset="-122"/>
-                <a:cs typeface="Consolas" pitchFamily="34" charset="-120"/>
+          </a:p>
+          <a:p>
+            <a:r>
+              <a:rPr sz="1000">
+                <a:solidFill>
+                  <a:srgbClr val="FFFFFF"/>
+                </a:solidFill>
+              </a:rPr>
+              <a:t>Done. PASS=29 WARN=0 ERROR=0 TOTAL=29</a:t>
+            </a:r>
+          </a:p>
+          <a:p/>
+          <a:p>
+            <a:r>
+              <a:rPr sz="1000">
+                <a:solidFill>
+                  <a:srgbClr val="FFFFFF"/>
+                </a:solidFill>
               </a:rPr>
               <a:t>docker compose run --rm dbt dbt build</a:t>
             </a:r>
-            <a:endParaRPr lang="en-US" sz="1050" dirty="0"/>
-          </a:p>
-          <a:p>
-            <a:pPr marL="0" indent="0">
-              <a:buNone/>
-            </a:pPr>
-            <a:r>
-              <a:rPr lang="en-US" sz="1050" dirty="0">
-                <a:solidFill>
-                  <a:srgbClr val="F8FAFC"/>
-                </a:solidFill>
-                <a:latin typeface="Consolas" pitchFamily="34" charset="0"/>
-                <a:ea typeface="Consolas" pitchFamily="34" charset="-122"/>
-                <a:cs typeface="Consolas" pitchFamily="34" charset="-120"/>
-              </a:rPr>
-              <a:t>Done. PASS=28 WARN=0 ERROR=0 TOTAL=28</a:t>
-            </a:r>
-            <a:endParaRPr lang="en-US" sz="1050" dirty="0"/>
+          </a:p>
+          <a:p>
+            <a:r>
+              <a:rPr sz="1000">
+                <a:solidFill>
+                  <a:srgbClr val="FFFFFF"/>
+                </a:solidFill>
+              </a:rPr>
+              <a:t>Found 10 models, 29 data tests, 10 sources, 479 macros</a:t>
+            </a:r>
+          </a:p>
+          <a:p>
+            <a:r>
+              <a:rPr sz="1000">
+                <a:solidFill>
+                  <a:srgbClr val="FFFFFF"/>
+                </a:solidFill>
+              </a:rPr>
+              <a:t>Done. PASS=34 WARN=0 ERROR=0 TOTAL=34</a:t>
+            </a:r>
           </a:p>
         </p:txBody>
       </p:sp>
@@ -2906,21 +2835,34 @@
           </a:bodyPr>
           <a:lstStyle/>
           <a:p>
-            <a:pPr marL="0" indent="0">
-              <a:buNone/>
-            </a:pPr>
-            <a:r>
-              <a:rPr lang="en-US" sz="1210" dirty="0">
-                <a:solidFill>
-                  <a:srgbClr val="0B1F33"/>
-                </a:solidFill>
-              </a:rPr>
-              <a:t>• not_null: campos essenciais de modelos Trusted e Delivery.
-• accepted_values: trimestre em 1–4; segmentos S1–S5; tipo_match válido.
-• singular tests: cardinalidade, granularidade, coerência do Glassdoor e faixa de match_percent.
-• Falha futura no relacionamento muitos-para-muitos gera erro automático.</a:t>
-            </a:r>
-            <a:endParaRPr lang="en-US" sz="1210" dirty="0"/>
+            <a:r>
+              <a:rPr sz="1200"/>
+              <a:t>• not_null: campos essenciais de modelos Trusted, Intermediate e Delivery.</a:t>
+            </a:r>
+          </a:p>
+          <a:p>
+            <a:r>
+              <a:rPr sz="1200"/>
+              <a:t>• accepted_values: trimestre em 1–4; segmentos S1–S5; tipo_match válido.</a:t>
+            </a:r>
+          </a:p>
+          <a:p>
+            <a:r>
+              <a:rPr sz="1200"/>
+              <a:t>• unique: CNPJ canônico único em `trusted.enquadramento`.</a:t>
+            </a:r>
+          </a:p>
+          <a:p>
+            <a:r>
+              <a:rPr sz="1200"/>
+              <a:t>• singular tests: cardinalidade, granularidade, coerência do Glassdoor e faixa de match_percent.</a:t>
+            </a:r>
+          </a:p>
+          <a:p>
+            <a:r>
+              <a:rPr sz="1200"/>
+              <a:t>• Build completo reconstrói modelos e executa testes no mesmo grafo dbt.</a:t>
+            </a:r>
           </a:p>
         </p:txBody>
       </p:sp>
@@ -3126,7 +3068,7 @@
                   <a:srgbClr val="667085"/>
                 </a:solidFill>
               </a:rPr>
-              <a:t>Trusted e Delivery foram exportadas para formato colunar e validadas por leitura de retorno.</a:t>
+              <a:t>A rotina exporta Trusted e Delivery em formato colunar; após a revisão de CNPJ, o Parquet de enquadramento deve ser regenerado.</a:t>
             </a:r>
             <a:endParaRPr lang="en-US" sz="950" dirty="0"/>
           </a:p>
@@ -3225,32 +3167,14 @@
           <a:bodyPr wrap="square" lIns="635" tIns="635" rIns="635" bIns="635" rtlCol="0" anchor="ctr"/>
           <a:lstStyle/>
           <a:p>
-            <a:pPr marL="0" indent="0" algn="ctr">
-              <a:buNone/>
-            </a:pPr>
-            <a:r>
-              <a:rPr lang="en-US" sz="1240" b="1" dirty="0">
-                <a:solidFill>
-                  <a:srgbClr val="1F5EFF"/>
-                </a:solidFill>
-              </a:rPr>
+            <a:r>
               <a:t>reclamacoes.parquet</a:t>
             </a:r>
-            <a:endParaRPr lang="en-US" sz="1240" dirty="0"/>
-          </a:p>
-          <a:p>
-            <a:pPr marL="0" indent="0" algn="ctr">
-              <a:buNone/>
-            </a:pPr>
-            <a:r>
-              <a:rPr lang="en-US" sz="1240" b="1" dirty="0">
-                <a:solidFill>
-                  <a:srgbClr val="1F5EFF"/>
-                </a:solidFill>
-              </a:rPr>
-              <a:t>918 linhas • 45.956 bytes</a:t>
-            </a:r>
-            <a:endParaRPr lang="en-US" sz="1240" dirty="0"/>
+          </a:p>
+          <a:p>
+            <a:r>
+              <a:t>918 linhas • validado</a:t>
+            </a:r>
           </a:p>
         </p:txBody>
       </p:sp>
@@ -3281,32 +3205,14 @@
           <a:bodyPr wrap="square" lIns="635" tIns="635" rIns="635" bIns="635" rtlCol="0" anchor="ctr"/>
           <a:lstStyle/>
           <a:p>
-            <a:pPr marL="0" indent="0" algn="ctr">
-              <a:buNone/>
-            </a:pPr>
-            <a:r>
-              <a:rPr lang="en-US" sz="1240" b="1" dirty="0">
-                <a:solidFill>
-                  <a:srgbClr val="00A6A6"/>
-                </a:solidFill>
-              </a:rPr>
+            <a:r>
               <a:t>enquadramento.parquet</a:t>
             </a:r>
-            <a:endParaRPr lang="en-US" sz="1240" dirty="0"/>
-          </a:p>
-          <a:p>
-            <a:pPr marL="0" indent="0" algn="ctr">
-              <a:buNone/>
-            </a:pPr>
-            <a:r>
-              <a:rPr lang="en-US" sz="1240" b="1" dirty="0">
-                <a:solidFill>
-                  <a:srgbClr val="00A6A6"/>
-                </a:solidFill>
-              </a:rPr>
-              <a:t>1.474 linhas • 80.867 bytes</a:t>
-            </a:r>
-            <a:endParaRPr lang="en-US" sz="1240" dirty="0"/>
+          </a:p>
+          <a:p>
+            <a:r>
+              <a:t>reexportar após revisão</a:t>
+            </a:r>
           </a:p>
         </p:txBody>
       </p:sp>
@@ -3337,32 +3243,14 @@
           <a:bodyPr wrap="square" lIns="635" tIns="635" rIns="635" bIns="635" rtlCol="0" anchor="ctr"/>
           <a:lstStyle/>
           <a:p>
-            <a:pPr marL="0" indent="0" algn="ctr">
-              <a:buNone/>
-            </a:pPr>
-            <a:r>
-              <a:rPr lang="en-US" sz="1240" b="1" dirty="0">
-                <a:solidFill>
-                  <a:srgbClr val="2E7D32"/>
-                </a:solidFill>
-              </a:rPr>
+            <a:r>
               <a:t>glassdoor.parquet</a:t>
             </a:r>
-            <a:endParaRPr lang="en-US" sz="1240" dirty="0"/>
-          </a:p>
-          <a:p>
-            <a:pPr marL="0" indent="0" algn="ctr">
-              <a:buNone/>
-            </a:pPr>
-            <a:r>
-              <a:rPr lang="en-US" sz="1240" b="1" dirty="0">
-                <a:solidFill>
-                  <a:srgbClr val="2E7D32"/>
-                </a:solidFill>
-              </a:rPr>
-              <a:t>39 linhas • 24.832 bytes</a:t>
-            </a:r>
-            <a:endParaRPr lang="en-US" sz="1240" dirty="0"/>
+          </a:p>
+          <a:p>
+            <a:r>
+              <a:t>39 linhas • validado</a:t>
+            </a:r>
           </a:p>
         </p:txBody>
       </p:sp>
@@ -3393,32 +3281,14 @@
           <a:bodyPr wrap="square" lIns="635" tIns="635" rIns="635" bIns="635" rtlCol="0" anchor="ctr"/>
           <a:lstStyle/>
           <a:p>
-            <a:pPr marL="0" indent="0" algn="ctr">
-              <a:buNone/>
-            </a:pPr>
-            <a:r>
-              <a:rPr lang="en-US" sz="1240" b="1" dirty="0">
-                <a:solidFill>
-                  <a:srgbClr val="F59E0B"/>
-                </a:solidFill>
-              </a:rPr>
+            <a:r>
               <a:t>tabela_final.parquet</a:t>
             </a:r>
-            <a:endParaRPr lang="en-US" sz="1240" dirty="0"/>
-          </a:p>
-          <a:p>
-            <a:pPr marL="0" indent="0" algn="ctr">
-              <a:buNone/>
-            </a:pPr>
-            <a:r>
-              <a:rPr lang="en-US" sz="1240" b="1" dirty="0">
-                <a:solidFill>
-                  <a:srgbClr val="F59E0B"/>
-                </a:solidFill>
-              </a:rPr>
-              <a:t>918 linhas • 67.973 bytes</a:t>
-            </a:r>
-            <a:endParaRPr lang="en-US" sz="1240" dirty="0"/>
+          </a:p>
+          <a:p>
+            <a:r>
+              <a:t>918 linhas • validado</a:t>
+            </a:r>
           </a:p>
         </p:txBody>
       </p:sp>
@@ -3451,89 +3321,54 @@
           </a:bodyPr>
           <a:lstStyle/>
           <a:p>
-            <a:pPr marL="0" indent="0">
-              <a:buNone/>
-            </a:pPr>
-            <a:r>
-              <a:rPr lang="en-US" sz="930" dirty="0">
-                <a:solidFill>
-                  <a:srgbClr val="F8FAFC"/>
-                </a:solidFill>
-                <a:latin typeface="Consolas" pitchFamily="34" charset="0"/>
-                <a:ea typeface="Consolas" pitchFamily="34" charset="-122"/>
-                <a:cs typeface="Consolas" pitchFamily="34" charset="-120"/>
+            <a:r>
+              <a:rPr sz="1000">
+                <a:solidFill>
+                  <a:srgbClr val="FFFFFF"/>
+                </a:solidFill>
               </a:rPr>
               <a:t>[OK] trusted.reclamacoes -&gt; linhas_banco=918 | linhas_parquet=918</a:t>
             </a:r>
-            <a:endParaRPr lang="en-US" sz="930" dirty="0"/>
-          </a:p>
-          <a:p>
-            <a:pPr marL="0" indent="0">
-              <a:buNone/>
-            </a:pPr>
-            <a:r>
-              <a:rPr lang="en-US" sz="930" dirty="0">
-                <a:solidFill>
-                  <a:srgbClr val="F8FAFC"/>
-                </a:solidFill>
-                <a:latin typeface="Consolas" pitchFamily="34" charset="0"/>
-                <a:ea typeface="Consolas" pitchFamily="34" charset="-122"/>
-                <a:cs typeface="Consolas" pitchFamily="34" charset="-120"/>
-              </a:rPr>
-              <a:t>[OK] trusted.enquadramento -&gt; linhas_banco=1474 | linhas_parquet=1474</a:t>
-            </a:r>
-            <a:endParaRPr lang="en-US" sz="930" dirty="0"/>
-          </a:p>
-          <a:p>
-            <a:pPr marL="0" indent="0">
-              <a:buNone/>
-            </a:pPr>
-            <a:r>
-              <a:rPr lang="en-US" sz="930" dirty="0">
-                <a:solidFill>
-                  <a:srgbClr val="F8FAFC"/>
-                </a:solidFill>
-                <a:latin typeface="Consolas" pitchFamily="34" charset="0"/>
-                <a:ea typeface="Consolas" pitchFamily="34" charset="-122"/>
-                <a:cs typeface="Consolas" pitchFamily="34" charset="-120"/>
+          </a:p>
+          <a:p>
+            <a:r>
+              <a:rPr sz="1000">
+                <a:solidFill>
+                  <a:srgbClr val="FFFFFF"/>
+                </a:solidFill>
+              </a:rPr>
+              <a:t>[ATENÇÃO] reexportar trusted.enquadramento após a deduplicação de CNPJ</a:t>
+            </a:r>
+          </a:p>
+          <a:p>
+            <a:r>
+              <a:rPr sz="1000">
+                <a:solidFill>
+                  <a:srgbClr val="FFFFFF"/>
+                </a:solidFill>
               </a:rPr>
               <a:t>[OK] trusted.glassdoor -&gt; linhas_banco=39 | linhas_parquet=39</a:t>
             </a:r>
-            <a:endParaRPr lang="en-US" sz="930" dirty="0"/>
-          </a:p>
-          <a:p>
-            <a:pPr marL="0" indent="0">
-              <a:buNone/>
-            </a:pPr>
-            <a:r>
-              <a:rPr lang="en-US" sz="930" dirty="0">
-                <a:solidFill>
-                  <a:srgbClr val="F8FAFC"/>
-                </a:solidFill>
-                <a:latin typeface="Consolas" pitchFamily="34" charset="0"/>
-                <a:ea typeface="Consolas" pitchFamily="34" charset="-122"/>
-                <a:cs typeface="Consolas" pitchFamily="34" charset="-120"/>
+          </a:p>
+          <a:p>
+            <a:r>
+              <a:rPr sz="1000">
+                <a:solidFill>
+                  <a:srgbClr val="FFFFFF"/>
+                </a:solidFill>
               </a:rPr>
               <a:t>[OK] delivery.tabela_final -&gt; linhas_banco=918 | linhas_parquet=918</a:t>
             </a:r>
-            <a:endParaRPr lang="en-US" sz="930" dirty="0"/>
-          </a:p>
-          <a:p>
-            <a:pPr marL="0" indent="0">
-              <a:buNone/>
-            </a:pPr>
-            <a:r>
-              <a:rPr lang="en-US" sz="930" dirty="0">
-                <a:solidFill>
-                  <a:srgbClr val="F8FAFC"/>
-                </a:solidFill>
-                <a:latin typeface="Consolas" pitchFamily="34" charset="0"/>
-                <a:ea typeface="Consolas" pitchFamily="34" charset="-122"/>
-                <a:cs typeface="Consolas" pitchFamily="34" charset="-120"/>
-              </a:rPr>
-              <a:t>EXPORTACAO CONCLUIDA COM SUCESSO</a:t>
-            </a:r>
-            <a:endParaRPr lang="en-US" sz="930" dirty="0"/>
+          </a:p>
+          <a:p>
+            <a:r>
+              <a:rPr sz="1000">
+                <a:solidFill>
+                  <a:srgbClr val="FFFFFF"/>
+                </a:solidFill>
+              </a:rPr>
+              <a:t>REEXECUTAR EXPORTACAO APOS REVISAO DE CNPJ</a:t>
+            </a:r>
           </a:p>
         </p:txBody>
       </p:sp>
@@ -3691,21 +3526,9 @@
           <a:bodyPr wrap="square" lIns="0" tIns="0" rIns="0" bIns="0" rtlCol="0" anchor="ctr"/>
           <a:lstStyle/>
           <a:p>
-            <a:pPr marL="0" indent="0">
-              <a:buNone/>
-            </a:pPr>
-            <a:r>
-              <a:rPr lang="en-US" sz="2400" b="1" dirty="0">
-                <a:solidFill>
-                  <a:srgbClr val="0B1F33"/>
-                </a:solidFill>
-                <a:latin typeface="Aptos Display" pitchFamily="34" charset="0"/>
-                <a:ea typeface="Aptos Display" pitchFamily="34" charset="-122"/>
-                <a:cs typeface="Aptos Display" pitchFamily="34" charset="-120"/>
-              </a:rPr>
-              <a:t>Dificuldades encontradas e decisões técnicas</a:t>
-            </a:r>
-            <a:endParaRPr lang="en-US" sz="2400" dirty="0"/>
+            <a:r>
+              <a:t>Aprimoramentos após avaliação</a:t>
+            </a:r>
           </a:p>
         </p:txBody>
       </p:sp>
@@ -3730,18 +3553,9 @@
           <a:bodyPr wrap="square" lIns="0" tIns="0" rIns="0" bIns="0" rtlCol="0" anchor="ctr"/>
           <a:lstStyle/>
           <a:p>
-            <a:pPr marL="0" indent="0">
-              <a:buNone/>
-            </a:pPr>
-            <a:r>
-              <a:rPr lang="en-US" sz="950" dirty="0">
-                <a:solidFill>
-                  <a:srgbClr val="667085"/>
-                </a:solidFill>
-              </a:rPr>
-              <a:t>A execução exigiu diagnósticos sucessivos, não apenas aplicação direta de comandos.</a:t>
-            </a:r>
-            <a:endParaRPr lang="en-US" sz="950" dirty="0"/>
+            <a:r>
+              <a:t>As críticas recebidas foram tratadas com mudanças estruturais no código, nos modelos dbt e nas evidências.</a:t>
+            </a:r>
           </a:p>
         </p:txBody>
       </p:sp>
@@ -3838,18 +3652,10 @@
           <a:bodyPr wrap="square" lIns="635" tIns="635" rIns="635" bIns="635" rtlCol="0" anchor="ctr"/>
           <a:lstStyle/>
           <a:p>
-            <a:pPr marL="0" indent="0" algn="ctr">
-              <a:buNone/>
-            </a:pPr>
-            <a:r>
-              <a:rPr lang="en-US" sz="1200" b="1" dirty="0">
-                <a:solidFill>
-                  <a:srgbClr val="1F5EFF"/>
-                </a:solidFill>
-              </a:rPr>
-              <a:t>Docker daemon</a:t>
-            </a:r>
-            <a:endParaRPr lang="en-US" sz="1200" dirty="0"/>
+            <a:r>
+              <a:rPr sz="1200"/>
+              <a:t>CNPJ duplicado</a:t>
+            </a:r>
           </a:p>
         </p:txBody>
       </p:sp>
@@ -3880,18 +3686,10 @@
           <a:bodyPr wrap="square" lIns="635" tIns="635" rIns="635" bIns="635" rtlCol="0" anchor="ctr"/>
           <a:lstStyle/>
           <a:p>
-            <a:pPr marL="0" indent="0" algn="ctr">
-              <a:buNone/>
-            </a:pPr>
-            <a:r>
-              <a:rPr lang="en-US" sz="1200" b="1" dirty="0">
-                <a:solidFill>
-                  <a:srgbClr val="F59E0B"/>
-                </a:solidFill>
-              </a:rPr>
-              <a:t>YAML inválido</a:t>
-            </a:r>
-            <a:endParaRPr lang="en-US" sz="1200" dirty="0"/>
+            <a:r>
+              <a:rPr sz="1200"/>
+              <a:t>Unicode U+0096</a:t>
+            </a:r>
           </a:p>
         </p:txBody>
       </p:sp>
@@ -3922,18 +3720,10 @@
           <a:bodyPr wrap="square" lIns="635" tIns="635" rIns="635" bIns="635" rtlCol="0" anchor="ctr"/>
           <a:lstStyle/>
           <a:p>
-            <a:pPr marL="0" indent="0" algn="ctr">
-              <a:buNone/>
-            </a:pPr>
-            <a:r>
-              <a:rPr lang="en-US" sz="1200" b="1" dirty="0">
-                <a:solidFill>
-                  <a:srgbClr val="C62828"/>
-                </a:solidFill>
-              </a:rPr>
-              <a:t>Parsing Glassdoor</a:t>
-            </a:r>
-            <a:endParaRPr lang="en-US" sz="1200" dirty="0"/>
+            <a:r>
+              <a:rPr sz="1200"/>
+              <a:t>dbt nativo</a:t>
+            </a:r>
           </a:p>
         </p:txBody>
       </p:sp>
@@ -3964,18 +3754,10 @@
           <a:bodyPr wrap="square" lIns="635" tIns="635" rIns="635" bIns="635" rtlCol="0" anchor="ctr"/>
           <a:lstStyle/>
           <a:p>
-            <a:pPr marL="0" indent="0" algn="ctr">
-              <a:buNone/>
-            </a:pPr>
-            <a:r>
-              <a:rPr lang="en-US" sz="1200" b="1" dirty="0">
-                <a:solidFill>
-                  <a:srgbClr val="6D28D9"/>
-                </a:solidFill>
-              </a:rPr>
-              <a:t>BOM UTF-8</a:t>
-            </a:r>
-            <a:endParaRPr lang="en-US" sz="1200" dirty="0"/>
+            <a:r>
+              <a:rPr sz="1200"/>
+              <a:t>Macro SQL</a:t>
+            </a:r>
           </a:p>
         </p:txBody>
       </p:sp>
@@ -4006,18 +3788,10 @@
           <a:bodyPr wrap="square" lIns="635" tIns="635" rIns="635" bIns="635" rtlCol="0" anchor="ctr"/>
           <a:lstStyle/>
           <a:p>
-            <a:pPr marL="0" indent="0" algn="ctr">
-              <a:buNone/>
-            </a:pPr>
-            <a:r>
-              <a:rPr lang="en-US" sz="1150" b="1" dirty="0">
-                <a:solidFill>
-                  <a:srgbClr val="00A6A6"/>
-                </a:solidFill>
-              </a:rPr>
-              <a:t>Aspas no PowerShell</a:t>
-            </a:r>
-            <a:endParaRPr lang="en-US" sz="1150" dirty="0"/>
+            <a:r>
+              <a:rPr sz="1200"/>
+              <a:t>Ephemeral</a:t>
+            </a:r>
           </a:p>
         </p:txBody>
       </p:sp>
@@ -4044,23 +3818,34 @@
           </a:bodyPr>
           <a:lstStyle/>
           <a:p>
-            <a:pPr marL="0" indent="0">
-              <a:buNone/>
-            </a:pPr>
-            <a:r>
-              <a:rPr lang="en-US" sz="1210" dirty="0">
-                <a:solidFill>
-                  <a:srgbClr val="0B1F33"/>
-                </a:solidFill>
-              </a:rPr>
-              <a:t>• O Docker Desktop precisou estar ativo para expor a API do engine Linux.
-• O docker-compose.yml foi recriado sem caracteres invisíveis para eliminar erro de parsing YAML.
-• Os arquivos Glassdoor usavam pipe `|`, não vírgula; a correção alterou 18 para 23 colunas válidas.
-• Colunas com U+0096 foram tratadas na Trusted via catálogo do PostgreSQL, sem alterar a RAW.
-• Arquivos SQL gerados no PowerShell exigiram remoção preventiva de BOM.
-• CNPJs duplicados e nomes múltiplos exigiram ranking para evitar row multiplication.</a:t>
-            </a:r>
-            <a:endParaRPr lang="en-US" sz="1210" dirty="0"/>
+            <a:r>
+              <a:rPr sz="1300"/>
+              <a:t>• CNPJs duplicados foram deduplicados na Trusted: 1.474 linhas de origem para 1.459 CNPJs canônicos.</a:t>
+            </a:r>
+          </a:p>
+          <a:p>
+            <a:r>
+              <a:rPr sz="1300"/>
+              <a:t>• Aliases preservam nomes alternativos, evitando perda de informação no matching.</a:t>
+            </a:r>
+          </a:p>
+          <a:p>
+            <a:r>
+              <a:rPr sz="1300"/>
+              <a:t>• O U+0096 passou a ser tratado por função reutilizável em `text_utils.py`.</a:t>
+            </a:r>
+          </a:p>
+          <a:p>
+            <a:r>
+              <a:rPr sz="1300"/>
+              <a:t>• A Delivery foi simplificada e passou a consumir quatro modelos `intermediate` via `ref()`.</a:t>
+            </a:r>
+          </a:p>
+          <a:p>
+            <a:r>
+              <a:rPr sz="1300"/>
+              <a:t>• A macro `normalizar_nome` centralizou regra textual antes repetida em SQL.</a:t>
+            </a:r>
           </a:p>
         </p:txBody>
       </p:sp>
@@ -4085,18 +3870,10 @@
           <a:bodyPr wrap="square" lIns="0" tIns="0" rIns="0" bIns="0" rtlCol="0" anchor="ctr"/>
           <a:lstStyle/>
           <a:p>
-            <a:pPr marL="0" indent="0" algn="ctr">
-              <a:buNone/>
-            </a:pPr>
-            <a:r>
-              <a:rPr lang="en-US" sz="1300" b="1" dirty="0">
-                <a:solidFill>
-                  <a:srgbClr val="2E7D32"/>
-                </a:solidFill>
-              </a:rPr>
-              <a:t>Lição metodológica: validação de esquema, cardinalidade e qualidade deve preceder qualquer integração analítica.</a:t>
-            </a:r>
-            <a:endParaRPr lang="en-US" sz="1300" dirty="0"/>
+            <a:r>
+              <a:rPr sz="1200"/>
+              <a:t>Lição metodológica: correções avaliativas devem ser incorporadas como regras testáveis e reutilizáveis, não como ajustes pontuais.</a:t>
+            </a:r>
           </a:p>
         </p:txBody>
       </p:sp>
@@ -4365,32 +4142,16 @@
           <a:bodyPr wrap="square" lIns="635" tIns="635" rIns="635" bIns="635" rtlCol="0" anchor="ctr"/>
           <a:lstStyle/>
           <a:p>
-            <a:pPr marL="0" indent="0" algn="ctr">
-              <a:buNone/>
-            </a:pPr>
-            <a:r>
-              <a:rPr lang="en-US" sz="1350" b="1" dirty="0">
-                <a:solidFill>
-                  <a:srgbClr val="1F5EFF"/>
-                </a:solidFill>
-              </a:rPr>
-              <a:t>Commit</a:t>
-            </a:r>
-            <a:endParaRPr lang="en-US" sz="1350" dirty="0"/>
-          </a:p>
-          <a:p>
-            <a:pPr marL="0" indent="0" algn="ctr">
-              <a:buNone/>
-            </a:pPr>
-            <a:r>
-              <a:rPr lang="en-US" sz="1350" b="1" dirty="0">
-                <a:solidFill>
-                  <a:srgbClr val="1F5EFF"/>
-                </a:solidFill>
-              </a:rPr>
-              <a:t>0f5bcd7</a:t>
-            </a:r>
-            <a:endParaRPr lang="en-US" sz="1350" dirty="0"/>
+            <a:r>
+              <a:rPr sz="1800"/>
+              <a:t>Refatoração dbt</a:t>
+            </a:r>
+          </a:p>
+          <a:p>
+            <a:r>
+              <a:rPr sz="1800"/>
+              <a:t>548668c</a:t>
+            </a:r>
           </a:p>
         </p:txBody>
       </p:sp>
@@ -4533,32 +4294,16 @@
           <a:bodyPr wrap="square" lIns="635" tIns="635" rIns="635" bIns="635" rtlCol="0" anchor="ctr"/>
           <a:lstStyle/>
           <a:p>
-            <a:pPr marL="0" indent="0" algn="ctr">
-              <a:buNone/>
-            </a:pPr>
-            <a:r>
-              <a:rPr lang="en-US" sz="1350" b="1" dirty="0">
-                <a:solidFill>
-                  <a:srgbClr val="F59E0B"/>
-                </a:solidFill>
-              </a:rPr>
-              <a:t>Working tree</a:t>
-            </a:r>
-            <a:endParaRPr lang="en-US" sz="1350" dirty="0"/>
-          </a:p>
-          <a:p>
-            <a:pPr marL="0" indent="0" algn="ctr">
-              <a:buNone/>
-            </a:pPr>
-            <a:r>
-              <a:rPr lang="en-US" sz="1350" b="1" dirty="0">
-                <a:solidFill>
-                  <a:srgbClr val="F59E0B"/>
-                </a:solidFill>
-              </a:rPr>
-              <a:t>clean</a:t>
-            </a:r>
-            <a:endParaRPr lang="en-US" sz="1350" dirty="0"/>
+            <a:r>
+              <a:rPr sz="1800"/>
+              <a:t>Build</a:t>
+            </a:r>
+          </a:p>
+          <a:p>
+            <a:r>
+              <a:rPr sz="1800"/>
+              <a:t>34/34 PASS</a:t>
+            </a:r>
           </a:p>
         </p:txBody>
       </p:sp>
@@ -4647,129 +4392,65 @@
           </a:bodyPr>
           <a:lstStyle/>
           <a:p>
-            <a:pPr marL="0" indent="0">
-              <a:buNone/>
-            </a:pPr>
-            <a:r>
-              <a:rPr lang="en-US" sz="1020" dirty="0">
-                <a:solidFill>
-                  <a:srgbClr val="F8FAFC"/>
-                </a:solidFill>
-                <a:latin typeface="Consolas" pitchFamily="34" charset="0"/>
-                <a:ea typeface="Consolas" pitchFamily="34" charset="-122"/>
-                <a:cs typeface="Consolas" pitchFamily="34" charset="-120"/>
-              </a:rPr>
-              <a:t>git push -u origin main</a:t>
-            </a:r>
-            <a:endParaRPr lang="en-US" sz="1020" dirty="0"/>
-          </a:p>
-          <a:p>
-            <a:pPr marL="0" indent="0">
-              <a:buNone/>
-            </a:pPr>
-            <a:r>
-              <a:rPr lang="en-US" sz="1020" dirty="0">
-                <a:solidFill>
-                  <a:srgbClr val="F8FAFC"/>
-                </a:solidFill>
-                <a:latin typeface="Consolas" pitchFamily="34" charset="0"/>
-                <a:ea typeface="Consolas" pitchFamily="34" charset="-122"/>
-                <a:cs typeface="Consolas" pitchFamily="34" charset="-120"/>
-              </a:rPr>
-              <a:t>[new branch] main -&gt; main</a:t>
-            </a:r>
-            <a:endParaRPr lang="en-US" sz="1020" dirty="0"/>
-          </a:p>
-          <a:p>
-            <a:pPr marL="0" indent="0">
-              <a:buNone/>
-            </a:pPr>
-            <a:r>
-              <a:rPr lang="en-US" sz="1020" dirty="0">
-                <a:solidFill>
-                  <a:srgbClr val="F8FAFC"/>
-                </a:solidFill>
-                <a:latin typeface="Consolas" pitchFamily="34" charset="0"/>
-                <a:ea typeface="Consolas" pitchFamily="34" charset="-122"/>
-                <a:cs typeface="Consolas" pitchFamily="34" charset="-120"/>
-              </a:rPr>
-              <a:t>branch main set up to track origin/main</a:t>
-            </a:r>
-            <a:endParaRPr lang="en-US" sz="1020" dirty="0"/>
-          </a:p>
-          <a:p>
-            <a:pPr marL="0" indent="0">
-              <a:buNone/>
-            </a:pPr>
-            <a:endParaRPr lang="en-US" sz="1020" dirty="0"/>
-          </a:p>
-          <a:p>
-            <a:pPr marL="0" indent="0">
-              <a:buNone/>
-            </a:pPr>
-            <a:r>
-              <a:rPr lang="en-US" sz="1020" dirty="0">
-                <a:solidFill>
-                  <a:srgbClr val="F8FAFC"/>
-                </a:solidFill>
-                <a:latin typeface="Consolas" pitchFamily="34" charset="0"/>
-                <a:ea typeface="Consolas" pitchFamily="34" charset="-122"/>
-                <a:cs typeface="Consolas" pitchFamily="34" charset="-120"/>
+            <a:r>
+              <a:rPr sz="1000">
+                <a:solidFill>
+                  <a:srgbClr val="FFFFFF"/>
+                </a:solidFill>
+              </a:rPr>
+              <a:t>git push origin main</a:t>
+            </a:r>
+          </a:p>
+          <a:p>
+            <a:r>
+              <a:rPr sz="1000">
+                <a:solidFill>
+                  <a:srgbClr val="FFFFFF"/>
+                </a:solidFill>
+              </a:rPr>
+              <a:t>4955f16..548668c  main -&gt; main</a:t>
+            </a:r>
+          </a:p>
+          <a:p/>
+          <a:p>
+            <a:r>
+              <a:rPr sz="1000">
+                <a:solidFill>
+                  <a:srgbClr val="FFFFFF"/>
+                </a:solidFill>
               </a:rPr>
               <a:t>git status</a:t>
             </a:r>
-            <a:endParaRPr lang="en-US" sz="1020" dirty="0"/>
-          </a:p>
-          <a:p>
-            <a:pPr marL="0" indent="0">
-              <a:buNone/>
-            </a:pPr>
-            <a:r>
-              <a:rPr lang="en-US" sz="1020" dirty="0">
-                <a:solidFill>
-                  <a:srgbClr val="F8FAFC"/>
-                </a:solidFill>
-                <a:latin typeface="Consolas" pitchFamily="34" charset="0"/>
-                <a:ea typeface="Consolas" pitchFamily="34" charset="-122"/>
-                <a:cs typeface="Consolas" pitchFamily="34" charset="-120"/>
+          </a:p>
+          <a:p>
+            <a:r>
+              <a:rPr sz="1000">
+                <a:solidFill>
+                  <a:srgbClr val="FFFFFF"/>
+                </a:solidFill>
               </a:rPr>
               <a:t>On branch main</a:t>
             </a:r>
-            <a:endParaRPr lang="en-US" sz="1020" dirty="0"/>
-          </a:p>
-          <a:p>
-            <a:pPr marL="0" indent="0">
-              <a:buNone/>
-            </a:pPr>
-            <a:r>
-              <a:rPr lang="en-US" sz="1020" dirty="0">
-                <a:solidFill>
-                  <a:srgbClr val="F8FAFC"/>
-                </a:solidFill>
-                <a:latin typeface="Consolas" pitchFamily="34" charset="0"/>
-                <a:ea typeface="Consolas" pitchFamily="34" charset="-122"/>
-                <a:cs typeface="Consolas" pitchFamily="34" charset="-120"/>
+          </a:p>
+          <a:p>
+            <a:r>
+              <a:rPr sz="1000">
+                <a:solidFill>
+                  <a:srgbClr val="FFFFFF"/>
+                </a:solidFill>
               </a:rPr>
               <a:t>Your branch is up to date with origin/main.</a:t>
             </a:r>
-            <a:endParaRPr lang="en-US" sz="1020" dirty="0"/>
-          </a:p>
-          <a:p>
-            <a:pPr marL="0" indent="0">
-              <a:buNone/>
-            </a:pPr>
-            <a:r>
-              <a:rPr lang="en-US" sz="1020" dirty="0">
-                <a:solidFill>
-                  <a:srgbClr val="F8FAFC"/>
-                </a:solidFill>
-                <a:latin typeface="Consolas" pitchFamily="34" charset="0"/>
-                <a:ea typeface="Consolas" pitchFamily="34" charset="-122"/>
-                <a:cs typeface="Consolas" pitchFamily="34" charset="-120"/>
+          </a:p>
+          <a:p>
+            <a:r>
+              <a:rPr sz="1000">
+                <a:solidFill>
+                  <a:srgbClr val="FFFFFF"/>
+                </a:solidFill>
               </a:rPr>
               <a:t>nothing to commit, working tree clean</a:t>
             </a:r>
-            <a:endParaRPr lang="en-US" sz="1020" dirty="0"/>
           </a:p>
         </p:txBody>
       </p:sp>
@@ -4796,22 +4477,34 @@
           </a:bodyPr>
           <a:lstStyle/>
           <a:p>
-            <a:pPr marL="0" indent="0">
-              <a:buNone/>
-            </a:pPr>
-            <a:r>
-              <a:rPr lang="en-US" sz="1230" dirty="0">
-                <a:solidFill>
-                  <a:srgbClr val="0B1F33"/>
-                </a:solidFill>
-              </a:rPr>
-              <a:t>• Dockerfiles e Compose para reexecução local.
-• Scripts Python para ingestão e exportação Parquet.
-• Modelos dbt para Trusted e Delivery.
-• Testes dbt e evidências de execução.
-• Dados de entrada e Parquets finais.</a:t>
-            </a:r>
-            <a:endParaRPr lang="en-US" sz="1230" dirty="0"/>
+            <a:r>
+              <a:rPr sz="1200"/>
+              <a:t>• Dockerfiles e Compose para reexecução local.</a:t>
+            </a:r>
+          </a:p>
+          <a:p>
+            <a:r>
+              <a:rPr sz="1200"/>
+              <a:t>• Scripts Python para ingestão, Unicode e exportação Parquet.</a:t>
+            </a:r>
+          </a:p>
+          <a:p>
+            <a:r>
+              <a:rPr sz="1200"/>
+              <a:t>• Modelos dbt Trusted, Intermediate e Delivery.</a:t>
+            </a:r>
+          </a:p>
+          <a:p>
+            <a:r>
+              <a:rPr sz="1200"/>
+              <a:t>• Macro `normalizar_nome` e testes automatizados.</a:t>
+            </a:r>
+          </a:p>
+          <a:p>
+            <a:r>
+              <a:rPr sz="1200"/>
+              <a:t>• Evidências das correções: CNPJ, Unicode e refatoração dbt.</a:t>
+            </a:r>
           </a:p>
         </p:txBody>
       </p:sp>
@@ -5380,32 +5073,16 @@
           <a:bodyPr wrap="square" lIns="635" tIns="635" rIns="635" bIns="635" rtlCol="0" anchor="ctr"/>
           <a:lstStyle/>
           <a:p>
-            <a:pPr marL="0" indent="0" algn="ctr">
-              <a:buNone/>
-            </a:pPr>
-            <a:r>
-              <a:rPr lang="en-US" sz="1280" b="1" dirty="0">
-                <a:solidFill>
-                  <a:srgbClr val="F59E0B"/>
-                </a:solidFill>
-              </a:rPr>
+            <a:r>
+              <a:rPr sz="1600"/>
               <a:t>Qualidade</a:t>
             </a:r>
-            <a:endParaRPr lang="en-US" sz="1280" dirty="0"/>
-          </a:p>
-          <a:p>
-            <a:pPr marL="0" indent="0" algn="ctr">
-              <a:buNone/>
-            </a:pPr>
-            <a:r>
-              <a:rPr lang="en-US" sz="1280" b="1" dirty="0">
-                <a:solidFill>
-                  <a:srgbClr val="F59E0B"/>
-                </a:solidFill>
-              </a:rPr>
-              <a:t>28/28 build</a:t>
-            </a:r>
-            <a:endParaRPr lang="en-US" sz="1280" dirty="0"/>
+          </a:p>
+          <a:p>
+            <a:r>
+              <a:rPr sz="1600"/>
+              <a:t>34/34 build</a:t>
+            </a:r>
           </a:p>
         </p:txBody>
       </p:sp>
@@ -5432,22 +5109,34 @@
           </a:bodyPr>
           <a:lstStyle/>
           <a:p>
-            <a:pPr marL="0" indent="0">
-              <a:buNone/>
-            </a:pPr>
-            <a:r>
-              <a:rPr lang="en-US" sz="1320" dirty="0">
-                <a:solidFill>
-                  <a:srgbClr val="0B1F33"/>
-                </a:solidFill>
-              </a:rPr>
-              <a:t>• A granularidade analítica foi preservada: 918 reclamações entraram na Delivery e 918 linhas foram produzidas.
-• A arquitetura RAW–Trusted–Delivery permitiu separar preservação da fonte, tratamento e consumo analítico.
-• Os testes dbt transformaram validações manuais em controles automatizados.
-• As limitações de matching foram explicitadas em indicadores de cobertura, sem correção manual não rastreável.
-• A publicação no GitHub garante transparência e reprodutibilidade da entrega.</a:t>
-            </a:r>
-            <a:endParaRPr lang="en-US" sz="1320" dirty="0"/>
+            <a:r>
+              <a:rPr sz="1300"/>
+              <a:t>• A granularidade analítica foi preservada: 918 reclamações entraram na Delivery e 918 linhas foram produzidas.</a:t>
+            </a:r>
+          </a:p>
+          <a:p>
+            <a:r>
+              <a:rPr sz="1300"/>
+              <a:t>• CNPJs duplicados foram tratados com canonicidade, aliases e testes de unicidade.</a:t>
+            </a:r>
+          </a:p>
+          <a:p>
+            <a:r>
+              <a:rPr sz="1300"/>
+              <a:t>• O U+0096 foi corrigido por função reutilizável na ingestão, sem afetar dados de negócio.</a:t>
+            </a:r>
+          </a:p>
+          <a:p>
+            <a:r>
+              <a:rPr sz="1300"/>
+              <a:t>• A transformação foi refatorada para DAG dbt com modelos `intermediate`, macro e `ref()`.</a:t>
+            </a:r>
+          </a:p>
+          <a:p>
+            <a:r>
+              <a:rPr sz="1300"/>
+              <a:t>• Os testes dbt transformaram validações manuais em controles automatizados.</a:t>
+            </a:r>
           </a:p>
         </p:txBody>
       </p:sp>
@@ -5472,18 +5161,10 @@
           <a:bodyPr wrap="square" lIns="0" tIns="0" rIns="0" bIns="0" rtlCol="0" anchor="ctr"/>
           <a:lstStyle/>
           <a:p>
-            <a:pPr marL="0" indent="0" algn="ctr">
-              <a:buNone/>
-            </a:pPr>
-            <a:r>
-              <a:rPr lang="en-US" sz="1400" b="1" dirty="0">
-                <a:solidFill>
-                  <a:srgbClr val="2E7D32"/>
-                </a:solidFill>
-              </a:rPr>
-              <a:t>Resultado central: uma solução completa de engenharia de dados, com evidências, testes e artefatos finais.</a:t>
-            </a:r>
-            <a:endParaRPr lang="en-US" sz="1400" dirty="0"/>
+            <a:r>
+              <a:rPr sz="1200"/>
+              <a:t>Resultado central: pipeline reprodutível, auditável e mais aderente aos recursos nativos do dbt.</a:t>
+            </a:r>
           </a:p>
         </p:txBody>
       </p:sp>
@@ -5748,18 +5429,10 @@
           </a:bodyPr>
           <a:lstStyle/>
           <a:p>
-            <a:pPr marL="0" indent="0">
-              <a:buNone/>
-            </a:pPr>
-            <a:r>
-              <a:rPr lang="en-US" sz="1080" dirty="0">
-                <a:solidFill>
-                  <a:srgbClr val="0B1F33"/>
-                </a:solidFill>
-              </a:rPr>
+            <a:r>
+              <a:rPr sz="800"/>
               <a:t>Apache Software Foundation. (2026). Apache Parquet. DOI: não atribuído. https://parquet.apache.org/</a:t>
             </a:r>
-            <a:endParaRPr lang="en-US" sz="1080" dirty="0"/>
           </a:p>
         </p:txBody>
       </p:sp>
@@ -5786,18 +5459,10 @@
           </a:bodyPr>
           <a:lstStyle/>
           <a:p>
-            <a:pPr marL="0" indent="0">
-              <a:buNone/>
-            </a:pPr>
-            <a:r>
-              <a:rPr lang="en-US" sz="1080" dirty="0">
-                <a:solidFill>
-                  <a:srgbClr val="0B1F33"/>
-                </a:solidFill>
-              </a:rPr>
-              <a:t>dbt Labs. (2026). Add data tests to your DAG. DOI: não atribuído. https://docs.getdbt.com/docs/build/data-tests</a:t>
-            </a:r>
-            <a:endParaRPr lang="en-US" sz="1080" dirty="0"/>
+            <a:r>
+              <a:rPr sz="800"/>
+              <a:t>dbt Labs. (2026). About dbt build command. DOI: não atribuído. https://docs.getdbt.com/reference/commands/build</a:t>
+            </a:r>
           </a:p>
         </p:txBody>
       </p:sp>
@@ -5824,18 +5489,10 @@
           </a:bodyPr>
           <a:lstStyle/>
           <a:p>
-            <a:pPr marL="0" indent="0">
-              <a:buNone/>
-            </a:pPr>
-            <a:r>
-              <a:rPr lang="en-US" sz="1080" dirty="0">
-                <a:solidFill>
-                  <a:srgbClr val="0B1F33"/>
-                </a:solidFill>
-              </a:rPr>
-              <a:t>dbt Labs. (2026). About dbt build command. DOI: não atribuído. https://docs.getdbt.com/reference/commands/build</a:t>
-            </a:r>
-            <a:endParaRPr lang="en-US" sz="1080" dirty="0"/>
+            <a:r>
+              <a:rPr sz="800"/>
+              <a:t>dbt Labs. (2026). Data tests. DOI: não atribuído. https://docs.getdbt.com/docs/build/data-tests</a:t>
+            </a:r>
           </a:p>
         </p:txBody>
       </p:sp>
@@ -5862,18 +5519,16 @@
           </a:bodyPr>
           <a:lstStyle/>
           <a:p>
-            <a:pPr marL="0" indent="0">
-              <a:buNone/>
-            </a:pPr>
-            <a:r>
-              <a:rPr lang="en-US" sz="1080" dirty="0">
-                <a:solidFill>
-                  <a:srgbClr val="0B1F33"/>
-                </a:solidFill>
-              </a:rPr>
-              <a:t>Docker Inc. (2026). Compose file reference. DOI: não atribuído. https://docs.docker.com/reference/compose-file/</a:t>
-            </a:r>
-            <a:endParaRPr lang="en-US" sz="1080" dirty="0"/>
+            <a:r>
+              <a:rPr sz="800"/>
+              <a:t>dbt Labs. (2026). Jinja and macros. DOI: não atribuído. https://docs.getdbt.com/docs/build/jinja-macros</a:t>
+            </a:r>
+          </a:p>
+          <a:p>
+            <a:r>
+              <a:rPr sz="800"/>
+              <a:t>dbt Labs. (2026). Materializations. DOI: não atribuído. https://docs.getdbt.com/docs/build/materializations</a:t>
+            </a:r>
           </a:p>
         </p:txBody>
       </p:sp>
@@ -5900,18 +5555,16 @@
           </a:bodyPr>
           <a:lstStyle/>
           <a:p>
-            <a:pPr marL="0" indent="0">
-              <a:buNone/>
-            </a:pPr>
-            <a:r>
-              <a:rPr lang="en-US" sz="1080" dirty="0">
-                <a:solidFill>
-                  <a:srgbClr val="0B1F33"/>
-                </a:solidFill>
-              </a:rPr>
-              <a:t>Docker Inc. (2026). Define services in Docker Compose. DOI: não atribuído. https://docs.docker.com/reference/compose-file/services/</a:t>
-            </a:r>
-            <a:endParaRPr lang="en-US" sz="1080" dirty="0"/>
+            <a:r>
+              <a:rPr sz="800"/>
+              <a:t>dbt Labs. (2026). ref function. DOI: não atribuído. https://docs.getdbt.com/reference/dbt-jinja-functions/ref</a:t>
+            </a:r>
+          </a:p>
+          <a:p>
+            <a:r>
+              <a:rPr sz="800"/>
+              <a:t>Docker Inc. (2026). Compose file reference. DOI: não atribuído. https://docs.docker.com/reference/compose-file/</a:t>
+            </a:r>
           </a:p>
         </p:txBody>
       </p:sp>
@@ -5938,18 +5591,10 @@
           </a:bodyPr>
           <a:lstStyle/>
           <a:p>
-            <a:pPr marL="0" indent="0">
-              <a:buNone/>
-            </a:pPr>
-            <a:r>
-              <a:rPr lang="en-US" sz="1080" dirty="0">
-                <a:solidFill>
-                  <a:srgbClr val="0B1F33"/>
-                </a:solidFill>
-              </a:rPr>
-              <a:t>The PostgreSQL Global Development Group. (2026). PostgreSQL Documentation: COPY. DOI: não atribuído. https://www.postgresql.org/docs/current/sql-copy.html</a:t>
-            </a:r>
-            <a:endParaRPr lang="en-US" sz="1080" dirty="0"/>
+            <a:r>
+              <a:rPr sz="800"/>
+              <a:t>The PostgreSQL Global Development Group. (2026). PostgreSQL Documentation. DOI: não atribuído. https://www.postgresql.org/docs/current/</a:t>
+            </a:r>
           </a:p>
         </p:txBody>
       </p:sp>
@@ -7803,242 +7448,174 @@
           </a:bodyPr>
           <a:lstStyle/>
           <a:p>
-            <a:pPr marL="0" indent="0">
-              <a:buNone/>
-            </a:pPr>
-            <a:r>
-              <a:rPr lang="en-US" sz="1070" dirty="0">
-                <a:solidFill>
-                  <a:srgbClr val="F8FAFC"/>
-                </a:solidFill>
-                <a:latin typeface="Consolas" pitchFamily="34" charset="0"/>
-                <a:ea typeface="Consolas" pitchFamily="34" charset="-122"/>
-                <a:cs typeface="Consolas" pitchFamily="34" charset="-120"/>
+            <a:r>
+              <a:rPr sz="1000">
+                <a:solidFill>
+                  <a:srgbClr val="FFFFFF"/>
+                </a:solidFill>
               </a:rPr>
               <a:t>Trabalho-04/</a:t>
             </a:r>
-            <a:endParaRPr lang="en-US" sz="1070" dirty="0"/>
-          </a:p>
-          <a:p>
-            <a:pPr marL="0" indent="0">
-              <a:buNone/>
-            </a:pPr>
-            <a:r>
-              <a:rPr lang="en-US" sz="1070" dirty="0">
-                <a:solidFill>
-                  <a:srgbClr val="F8FAFC"/>
-                </a:solidFill>
-                <a:latin typeface="Consolas" pitchFamily="34" charset="0"/>
-                <a:ea typeface="Consolas" pitchFamily="34" charset="-122"/>
-                <a:cs typeface="Consolas" pitchFamily="34" charset="-120"/>
+          </a:p>
+          <a:p>
+            <a:r>
+              <a:rPr sz="1000">
+                <a:solidFill>
+                  <a:srgbClr val="FFFFFF"/>
+                </a:solidFill>
               </a:rPr>
               <a:t>├─ Dockerfile.python    ├─ Dockerfile.dbt</a:t>
             </a:r>
-            <a:endParaRPr lang="en-US" sz="1070" dirty="0"/>
-          </a:p>
-          <a:p>
-            <a:pPr marL="0" indent="0">
-              <a:buNone/>
-            </a:pPr>
-            <a:r>
-              <a:rPr lang="en-US" sz="1070" dirty="0">
-                <a:solidFill>
-                  <a:srgbClr val="F8FAFC"/>
-                </a:solidFill>
-                <a:latin typeface="Consolas" pitchFamily="34" charset="0"/>
-                <a:ea typeface="Consolas" pitchFamily="34" charset="-122"/>
-                <a:cs typeface="Consolas" pitchFamily="34" charset="-120"/>
+          </a:p>
+          <a:p>
+            <a:r>
+              <a:rPr sz="1000">
+                <a:solidFill>
+                  <a:srgbClr val="FFFFFF"/>
+                </a:solidFill>
               </a:rPr>
               <a:t>├─ docker-compose.yml   ├─ requirements.txt</a:t>
             </a:r>
-            <a:endParaRPr lang="en-US" sz="1070" dirty="0"/>
-          </a:p>
-          <a:p>
-            <a:pPr marL="0" indent="0">
-              <a:buNone/>
-            </a:pPr>
-            <a:r>
-              <a:rPr lang="en-US" sz="1070" dirty="0">
-                <a:solidFill>
-                  <a:srgbClr val="F8FAFC"/>
-                </a:solidFill>
-                <a:latin typeface="Consolas" pitchFamily="34" charset="0"/>
-                <a:ea typeface="Consolas" pitchFamily="34" charset="-122"/>
-                <a:cs typeface="Consolas" pitchFamily="34" charset="-120"/>
+          </a:p>
+          <a:p>
+            <a:r>
+              <a:rPr sz="1000">
+                <a:solidFill>
+                  <a:srgbClr val="FFFFFF"/>
+                </a:solidFill>
               </a:rPr>
               <a:t>├─ scripts/</a:t>
             </a:r>
-            <a:endParaRPr lang="en-US" sz="1070" dirty="0"/>
-          </a:p>
-          <a:p>
-            <a:pPr marL="0" indent="0">
-              <a:buNone/>
-            </a:pPr>
-            <a:r>
-              <a:rPr lang="en-US" sz="1070" dirty="0">
-                <a:solidFill>
-                  <a:srgbClr val="F8FAFC"/>
-                </a:solidFill>
-                <a:latin typeface="Consolas" pitchFamily="34" charset="0"/>
-                <a:ea typeface="Consolas" pitchFamily="34" charset="-122"/>
-                <a:cs typeface="Consolas" pitchFamily="34" charset="-120"/>
+          </a:p>
+          <a:p>
+            <a:r>
+              <a:rPr sz="1000">
+                <a:solidFill>
+                  <a:srgbClr val="FFFFFF"/>
+                </a:solidFill>
               </a:rPr>
               <a:t>│  ├─ ingest_raw.py</a:t>
             </a:r>
-            <a:endParaRPr lang="en-US" sz="1070" dirty="0"/>
-          </a:p>
-          <a:p>
-            <a:pPr marL="0" indent="0">
-              <a:buNone/>
-            </a:pPr>
-            <a:r>
-              <a:rPr lang="en-US" sz="1070" dirty="0">
-                <a:solidFill>
-                  <a:srgbClr val="F8FAFC"/>
-                </a:solidFill>
-                <a:latin typeface="Consolas" pitchFamily="34" charset="0"/>
-                <a:ea typeface="Consolas" pitchFamily="34" charset="-122"/>
-                <a:cs typeface="Consolas" pitchFamily="34" charset="-120"/>
+          </a:p>
+          <a:p>
+            <a:r>
+              <a:rPr sz="1000">
+                <a:solidFill>
+                  <a:srgbClr val="FFFFFF"/>
+                </a:solidFill>
+              </a:rPr>
+              <a:t>│  ├─ text_utils.py</a:t>
+            </a:r>
+          </a:p>
+          <a:p>
+            <a:r>
+              <a:rPr sz="1000">
+                <a:solidFill>
+                  <a:srgbClr val="FFFFFF"/>
+                </a:solidFill>
               </a:rPr>
               <a:t>│  └─ export_parquet.py</a:t>
             </a:r>
-            <a:endParaRPr lang="en-US" sz="1070" dirty="0"/>
-          </a:p>
-          <a:p>
-            <a:pPr marL="0" indent="0">
-              <a:buNone/>
-            </a:pPr>
-            <a:r>
-              <a:rPr lang="en-US" sz="1070" dirty="0">
-                <a:solidFill>
-                  <a:srgbClr val="F8FAFC"/>
-                </a:solidFill>
-                <a:latin typeface="Consolas" pitchFamily="34" charset="0"/>
-                <a:ea typeface="Consolas" pitchFamily="34" charset="-122"/>
-                <a:cs typeface="Consolas" pitchFamily="34" charset="-120"/>
+          </a:p>
+          <a:p>
+            <a:r>
+              <a:rPr sz="1000">
+                <a:solidFill>
+                  <a:srgbClr val="FFFFFF"/>
+                </a:solidFill>
               </a:rPr>
               <a:t>├─ dbt/</a:t>
             </a:r>
-            <a:endParaRPr lang="en-US" sz="1070" dirty="0"/>
-          </a:p>
-          <a:p>
-            <a:pPr marL="0" indent="0">
-              <a:buNone/>
-            </a:pPr>
-            <a:r>
-              <a:rPr lang="en-US" sz="1070" dirty="0">
-                <a:solidFill>
-                  <a:srgbClr val="F8FAFC"/>
-                </a:solidFill>
-                <a:latin typeface="Consolas" pitchFamily="34" charset="0"/>
-                <a:ea typeface="Consolas" pitchFamily="34" charset="-122"/>
-                <a:cs typeface="Consolas" pitchFamily="34" charset="-120"/>
+          </a:p>
+          <a:p>
+            <a:r>
+              <a:rPr sz="1000">
+                <a:solidFill>
+                  <a:srgbClr val="FFFFFF"/>
+                </a:solidFill>
+              </a:rPr>
+              <a:t>│  ├─ macros/normalizar_nome.sql</a:t>
+            </a:r>
+          </a:p>
+          <a:p>
+            <a:r>
+              <a:rPr sz="1000">
+                <a:solidFill>
+                  <a:srgbClr val="FFFFFF"/>
+                </a:solidFill>
               </a:rPr>
               <a:t>│  ├─ models/trusted/</a:t>
             </a:r>
-            <a:endParaRPr lang="en-US" sz="1070" dirty="0"/>
-          </a:p>
-          <a:p>
-            <a:pPr marL="0" indent="0">
-              <a:buNone/>
-            </a:pPr>
-            <a:r>
-              <a:rPr lang="en-US" sz="1070" dirty="0">
-                <a:solidFill>
-                  <a:srgbClr val="F8FAFC"/>
-                </a:solidFill>
-                <a:latin typeface="Consolas" pitchFamily="34" charset="0"/>
-                <a:ea typeface="Consolas" pitchFamily="34" charset="-122"/>
-                <a:cs typeface="Consolas" pitchFamily="34" charset="-120"/>
+          </a:p>
+          <a:p>
+            <a:r>
+              <a:rPr sz="1000">
+                <a:solidFill>
+                  <a:srgbClr val="FFFFFF"/>
+                </a:solidFill>
+              </a:rPr>
+              <a:t>│  ├─ models/intermediate/</a:t>
+            </a:r>
+          </a:p>
+          <a:p>
+            <a:r>
+              <a:rPr sz="1000">
+                <a:solidFill>
+                  <a:srgbClr val="FFFFFF"/>
+                </a:solidFill>
               </a:rPr>
               <a:t>│  ├─ models/delivery/</a:t>
             </a:r>
-            <a:endParaRPr lang="en-US" sz="1070" dirty="0"/>
-          </a:p>
-          <a:p>
-            <a:pPr marL="0" indent="0">
-              <a:buNone/>
-            </a:pPr>
-            <a:r>
-              <a:rPr lang="en-US" sz="1070" dirty="0">
-                <a:solidFill>
-                  <a:srgbClr val="F8FAFC"/>
-                </a:solidFill>
-                <a:latin typeface="Consolas" pitchFamily="34" charset="0"/>
-                <a:ea typeface="Consolas" pitchFamily="34" charset="-122"/>
-                <a:cs typeface="Consolas" pitchFamily="34" charset="-120"/>
+          </a:p>
+          <a:p>
+            <a:r>
+              <a:rPr sz="1000">
+                <a:solidFill>
+                  <a:srgbClr val="FFFFFF"/>
+                </a:solidFill>
               </a:rPr>
               <a:t>│  └─ tests/</a:t>
             </a:r>
-            <a:endParaRPr lang="en-US" sz="1070" dirty="0"/>
-          </a:p>
-          <a:p>
-            <a:pPr marL="0" indent="0">
-              <a:buNone/>
-            </a:pPr>
-            <a:r>
-              <a:rPr lang="en-US" sz="1070" dirty="0">
-                <a:solidFill>
-                  <a:srgbClr val="F8FAFC"/>
-                </a:solidFill>
-                <a:latin typeface="Consolas" pitchFamily="34" charset="0"/>
-                <a:ea typeface="Consolas" pitchFamily="34" charset="-122"/>
-                <a:cs typeface="Consolas" pitchFamily="34" charset="-120"/>
+          </a:p>
+          <a:p>
+            <a:r>
+              <a:rPr sz="1000">
+                <a:solidFill>
+                  <a:srgbClr val="FFFFFF"/>
+                </a:solidFill>
               </a:rPr>
               <a:t>├─ data/input/</a:t>
             </a:r>
-            <a:endParaRPr lang="en-US" sz="1070" dirty="0"/>
-          </a:p>
-          <a:p>
-            <a:pPr marL="0" indent="0">
-              <a:buNone/>
-            </a:pPr>
-            <a:r>
-              <a:rPr lang="en-US" sz="1070" dirty="0">
-                <a:solidFill>
-                  <a:srgbClr val="F8FAFC"/>
-                </a:solidFill>
-                <a:latin typeface="Consolas" pitchFamily="34" charset="0"/>
-                <a:ea typeface="Consolas" pitchFamily="34" charset="-122"/>
-                <a:cs typeface="Consolas" pitchFamily="34" charset="-120"/>
+          </a:p>
+          <a:p>
+            <a:r>
+              <a:rPr sz="1000">
+                <a:solidFill>
+                  <a:srgbClr val="FFFFFF"/>
+                </a:solidFill>
               </a:rPr>
               <a:t>├─ data/trusted/*.parquet</a:t>
             </a:r>
-            <a:endParaRPr lang="en-US" sz="1070" dirty="0"/>
-          </a:p>
-          <a:p>
-            <a:pPr marL="0" indent="0">
-              <a:buNone/>
-            </a:pPr>
-            <a:r>
-              <a:rPr lang="en-US" sz="1070" dirty="0">
-                <a:solidFill>
-                  <a:srgbClr val="F8FAFC"/>
-                </a:solidFill>
-                <a:latin typeface="Consolas" pitchFamily="34" charset="0"/>
-                <a:ea typeface="Consolas" pitchFamily="34" charset="-122"/>
-                <a:cs typeface="Consolas" pitchFamily="34" charset="-120"/>
+          </a:p>
+          <a:p>
+            <a:r>
+              <a:rPr sz="1000">
+                <a:solidFill>
+                  <a:srgbClr val="FFFFFF"/>
+                </a:solidFill>
               </a:rPr>
               <a:t>├─ data/delivery/tabela_final.parquet</a:t>
             </a:r>
-            <a:endParaRPr lang="en-US" sz="1070" dirty="0"/>
-          </a:p>
-          <a:p>
-            <a:pPr marL="0" indent="0">
-              <a:buNone/>
-            </a:pPr>
-            <a:r>
-              <a:rPr lang="en-US" sz="1070" dirty="0">
-                <a:solidFill>
-                  <a:srgbClr val="F8FAFC"/>
-                </a:solidFill>
-                <a:latin typeface="Consolas" pitchFamily="34" charset="0"/>
-                <a:ea typeface="Consolas" pitchFamily="34" charset="-122"/>
-                <a:cs typeface="Consolas" pitchFamily="34" charset="-120"/>
+          </a:p>
+          <a:p>
+            <a:r>
+              <a:rPr sz="1000">
+                <a:solidFill>
+                  <a:srgbClr val="FFFFFF"/>
+                </a:solidFill>
               </a:rPr>
               <a:t>└─ evidencias/</a:t>
             </a:r>
-            <a:endParaRPr lang="en-US" sz="1070" dirty="0"/>
           </a:p>
         </p:txBody>
       </p:sp>
@@ -8063,18 +7640,10 @@
           <a:bodyPr wrap="square" lIns="0" tIns="0" rIns="0" bIns="0" rtlCol="0" anchor="ctr"/>
           <a:lstStyle/>
           <a:p>
-            <a:pPr marL="0" indent="0" algn="ctr">
-              <a:buNone/>
-            </a:pPr>
-            <a:r>
-              <a:rPr lang="en-US" sz="2600" b="1" dirty="0">
-                <a:solidFill>
-                  <a:srgbClr val="1F5EFF"/>
-                </a:solidFill>
-              </a:rPr>
-              <a:t>61</a:t>
-            </a:r>
-            <a:endParaRPr lang="en-US" sz="2600" dirty="0"/>
+            <a:r>
+              <a:rPr sz="2600"/>
+              <a:t>70+</a:t>
+            </a:r>
           </a:p>
         </p:txBody>
       </p:sp>
@@ -8137,18 +7706,10 @@
           <a:bodyPr wrap="square" lIns="0" tIns="0" rIns="0" bIns="0" rtlCol="0" anchor="ctr"/>
           <a:lstStyle/>
           <a:p>
-            <a:pPr marL="0" indent="0" algn="ctr">
-              <a:buNone/>
-            </a:pPr>
-            <a:r>
-              <a:rPr lang="en-US" sz="2600" b="1" dirty="0">
-                <a:solidFill>
-                  <a:srgbClr val="00A6A6"/>
-                </a:solidFill>
-              </a:rPr>
-              <a:t>4</a:t>
-            </a:r>
-            <a:endParaRPr lang="en-US" sz="2600" dirty="0"/>
+            <a:r>
+              <a:rPr sz="2600"/>
+              <a:t>10</a:t>
+            </a:r>
           </a:p>
         </p:txBody>
       </p:sp>
@@ -8175,18 +7736,10 @@
           </a:bodyPr>
           <a:lstStyle/>
           <a:p>
-            <a:pPr marL="0" indent="0" algn="ctr">
-              <a:buNone/>
-            </a:pPr>
-            <a:r>
-              <a:rPr lang="en-US" sz="950" dirty="0">
-                <a:solidFill>
-                  <a:srgbClr val="667085"/>
-                </a:solidFill>
-              </a:rPr>
+            <a:r>
+              <a:rPr sz="1000"/>
               <a:t>modelos dbt</a:t>
             </a:r>
-            <a:endParaRPr lang="en-US" sz="950" dirty="0"/>
           </a:p>
         </p:txBody>
       </p:sp>
@@ -8211,18 +7764,10 @@
           <a:bodyPr wrap="square" lIns="0" tIns="0" rIns="0" bIns="0" rtlCol="0" anchor="ctr"/>
           <a:lstStyle/>
           <a:p>
-            <a:pPr marL="0" indent="0" algn="ctr">
-              <a:buNone/>
-            </a:pPr>
-            <a:r>
-              <a:rPr lang="en-US" sz="2600" b="1" dirty="0">
-                <a:solidFill>
-                  <a:srgbClr val="2E7D32"/>
-                </a:solidFill>
-              </a:rPr>
-              <a:t>24</a:t>
-            </a:r>
-            <a:endParaRPr lang="en-US" sz="2600" dirty="0"/>
+            <a:r>
+              <a:rPr sz="2600"/>
+              <a:t>29</a:t>
+            </a:r>
           </a:p>
         </p:txBody>
       </p:sp>
@@ -8249,18 +7794,10 @@
           </a:bodyPr>
           <a:lstStyle/>
           <a:p>
-            <a:pPr marL="0" indent="0" algn="ctr">
-              <a:buNone/>
-            </a:pPr>
-            <a:r>
-              <a:rPr lang="en-US" sz="950" dirty="0">
-                <a:solidFill>
-                  <a:srgbClr val="667085"/>
-                </a:solidFill>
-              </a:rPr>
+            <a:r>
+              <a:rPr sz="1000"/>
               <a:t>testes de dados</a:t>
             </a:r>
-            <a:endParaRPr lang="en-US" sz="950" dirty="0"/>
           </a:p>
         </p:txBody>
       </p:sp>
@@ -8285,18 +7822,14 @@
           <a:bodyPr wrap="square" lIns="0" tIns="0" rIns="0" bIns="0" rtlCol="0" anchor="ctr"/>
           <a:lstStyle/>
           <a:p>
-            <a:pPr marL="0" indent="0" algn="ctr">
-              <a:buNone/>
-            </a:pPr>
-            <a:r>
-              <a:rPr lang="en-US" sz="2600" b="1" dirty="0">
-                <a:solidFill>
-                  <a:srgbClr val="F59E0B"/>
+            <a:r>
+              <a:rPr sz="2600">
+                <a:solidFill>
+                  <a:srgbClr val="000000"/>
                 </a:solidFill>
               </a:rPr>
               <a:t>4</a:t>
             </a:r>
-            <a:endParaRPr lang="en-US" sz="2600" dirty="0"/>
           </a:p>
         </p:txBody>
       </p:sp>
@@ -8359,18 +7892,16 @@
           <a:bodyPr wrap="square" lIns="0" tIns="0" rIns="0" bIns="0" rtlCol="0" anchor="ctr"/>
           <a:lstStyle/>
           <a:p>
-            <a:pPr marL="0" indent="0" algn="ctr">
-              <a:buNone/>
-            </a:pPr>
-            <a:r>
-              <a:rPr lang="en-US" sz="2600" b="1" dirty="0">
-                <a:solidFill>
-                  <a:srgbClr val="6D28D9"/>
-                </a:solidFill>
-              </a:rPr>
-              <a:t>0f5bcd7</a:t>
-            </a:r>
-            <a:endParaRPr lang="en-US" sz="2600" dirty="0"/>
+            <a:r>
+              <a:rPr sz="1800"/>
+              <a:t>main</a:t>
+            </a:r>
+          </a:p>
+          <a:p>
+            <a:r>
+              <a:rPr sz="1800"/>
+              <a:t>commits de revisão</a:t>
+            </a:r>
           </a:p>
         </p:txBody>
       </p:sp>
@@ -9049,163 +8580,127 @@
           </a:bodyPr>
           <a:lstStyle/>
           <a:p>
-            <a:pPr marL="0" indent="0">
-              <a:buNone/>
-            </a:pPr>
-            <a:r>
-              <a:rPr lang="en-US" sz="950" dirty="0">
-                <a:solidFill>
-                  <a:srgbClr val="F8FAFC"/>
-                </a:solidFill>
-                <a:latin typeface="Consolas" pitchFamily="34" charset="0"/>
-                <a:ea typeface="Consolas" pitchFamily="34" charset="-122"/>
-                <a:cs typeface="Consolas" pitchFamily="34" charset="-120"/>
+            <a:r>
+              <a:rPr sz="1000">
+                <a:solidFill>
+                  <a:srgbClr val="FFFFFF"/>
+                </a:solidFill>
+              </a:rPr>
+              <a:t>from text_utils import normalize_dataframe_columns</a:t>
+            </a:r>
+          </a:p>
+          <a:p/>
+          <a:p>
+            <a:r>
+              <a:rPr sz="1000">
+                <a:solidFill>
+                  <a:srgbClr val="FFFFFF"/>
+                </a:solidFill>
               </a:rPr>
               <a:t>def read_file(path):</a:t>
             </a:r>
-            <a:endParaRPr lang="en-US" sz="950" dirty="0"/>
-          </a:p>
-          <a:p>
-            <a:pPr marL="0" indent="0">
-              <a:buNone/>
-            </a:pPr>
-            <a:r>
-              <a:rPr lang="en-US" sz="950" dirty="0">
-                <a:solidFill>
-                  <a:srgbClr val="F8FAFC"/>
-                </a:solidFill>
-                <a:latin typeface="Consolas" pitchFamily="34" charset="0"/>
-                <a:ea typeface="Consolas" pitchFamily="34" charset="-122"/>
-                <a:cs typeface="Consolas" pitchFamily="34" charset="-120"/>
+          </a:p>
+          <a:p>
+            <a:r>
+              <a:rPr sz="1000">
+                <a:solidFill>
+                  <a:srgbClr val="FFFFFF"/>
+                </a:solidFill>
               </a:rPr>
               <a:t>    if path.suffix == ".tsv":</a:t>
             </a:r>
-            <a:endParaRPr lang="en-US" sz="950" dirty="0"/>
-          </a:p>
-          <a:p>
-            <a:pPr marL="0" indent="0">
-              <a:buNone/>
-            </a:pPr>
-            <a:r>
-              <a:rPr lang="en-US" sz="950" dirty="0">
-                <a:solidFill>
-                  <a:srgbClr val="F8FAFC"/>
-                </a:solidFill>
-                <a:latin typeface="Consolas" pitchFamily="34" charset="0"/>
-                <a:ea typeface="Consolas" pitchFamily="34" charset="-122"/>
-                <a:cs typeface="Consolas" pitchFamily="34" charset="-120"/>
+          </a:p>
+          <a:p>
+            <a:r>
+              <a:rPr sz="1000">
+                <a:solidFill>
+                  <a:srgbClr val="FFFFFF"/>
+                </a:solidFill>
               </a:rPr>
               <a:t>        return pd.read_csv(path, sep="\t", dtype=str)</a:t>
             </a:r>
-            <a:endParaRPr lang="en-US" sz="950" dirty="0"/>
-          </a:p>
-          <a:p>
-            <a:pPr marL="0" indent="0">
-              <a:buNone/>
-            </a:pPr>
-            <a:r>
-              <a:rPr lang="en-US" sz="950" dirty="0">
-                <a:solidFill>
-                  <a:srgbClr val="F8FAFC"/>
-                </a:solidFill>
-                <a:latin typeface="Consolas" pitchFamily="34" charset="0"/>
-                <a:ea typeface="Consolas" pitchFamily="34" charset="-122"/>
-                <a:cs typeface="Consolas" pitchFamily="34" charset="-120"/>
+          </a:p>
+          <a:p>
+            <a:r>
+              <a:rPr sz="1000">
+                <a:solidFill>
+                  <a:srgbClr val="FFFFFF"/>
+                </a:solidFill>
               </a:rPr>
               <a:t>    if filename.startswith("glassdoor_"):</a:t>
             </a:r>
-            <a:endParaRPr lang="en-US" sz="950" dirty="0"/>
-          </a:p>
-          <a:p>
-            <a:pPr marL="0" indent="0">
-              <a:buNone/>
-            </a:pPr>
-            <a:r>
-              <a:rPr lang="en-US" sz="950" dirty="0">
-                <a:solidFill>
-                  <a:srgbClr val="F8FAFC"/>
-                </a:solidFill>
-                <a:latin typeface="Consolas" pitchFamily="34" charset="0"/>
-                <a:ea typeface="Consolas" pitchFamily="34" charset="-122"/>
-                <a:cs typeface="Consolas" pitchFamily="34" charset="-120"/>
+          </a:p>
+          <a:p>
+            <a:r>
+              <a:rPr sz="1000">
+                <a:solidFill>
+                  <a:srgbClr val="FFFFFF"/>
+                </a:solidFill>
               </a:rPr>
               <a:t>        return pd.read_csv(path, sep="|", dtype=str)</a:t>
             </a:r>
-            <a:endParaRPr lang="en-US" sz="950" dirty="0"/>
-          </a:p>
-          <a:p>
-            <a:pPr marL="0" indent="0">
-              <a:buNone/>
-            </a:pPr>
-            <a:r>
-              <a:rPr lang="en-US" sz="950" dirty="0">
-                <a:solidFill>
-                  <a:srgbClr val="F8FAFC"/>
-                </a:solidFill>
-                <a:latin typeface="Consolas" pitchFamily="34" charset="0"/>
-                <a:ea typeface="Consolas" pitchFamily="34" charset="-122"/>
-                <a:cs typeface="Consolas" pitchFamily="34" charset="-120"/>
+          </a:p>
+          <a:p>
+            <a:r>
+              <a:rPr sz="1000">
+                <a:solidFill>
+                  <a:srgbClr val="FFFFFF"/>
+                </a:solidFill>
               </a:rPr>
               <a:t>    return pd.read_csv(path, sep=None, engine="python", dtype=str)</a:t>
             </a:r>
-            <a:endParaRPr lang="en-US" sz="950" dirty="0"/>
-          </a:p>
-          <a:p>
-            <a:pPr marL="0" indent="0">
-              <a:buNone/>
-            </a:pPr>
-            <a:endParaRPr lang="en-US" sz="950" dirty="0"/>
-          </a:p>
-          <a:p>
-            <a:pPr marL="0" indent="0">
-              <a:buNone/>
-            </a:pPr>
-            <a:r>
-              <a:rPr lang="en-US" sz="950" dirty="0">
-                <a:solidFill>
-                  <a:srgbClr val="F8FAFC"/>
-                </a:solidFill>
-                <a:latin typeface="Consolas" pitchFamily="34" charset="0"/>
-                <a:ea typeface="Consolas" pitchFamily="34" charset="-122"/>
-                <a:cs typeface="Consolas" pitchFamily="34" charset="-120"/>
+          </a:p>
+          <a:p/>
+          <a:p>
+            <a:r>
+              <a:rPr sz="1000">
+                <a:solidFill>
+                  <a:srgbClr val="FFFFFF"/>
+                </a:solidFill>
+              </a:rPr>
+              <a:t>df = read_file(path)</a:t>
+            </a:r>
+          </a:p>
+          <a:p>
+            <a:r>
+              <a:rPr sz="1000">
+                <a:solidFill>
+                  <a:srgbClr val="FFFFFF"/>
+                </a:solidFill>
+              </a:rPr>
+              <a:t>df = normalize_dataframe_columns(df)</a:t>
+            </a:r>
+          </a:p>
+          <a:p/>
+          <a:p>
+            <a:r>
+              <a:rPr sz="1000">
+                <a:solidFill>
+                  <a:srgbClr val="FFFFFF"/>
+                </a:solidFill>
               </a:rPr>
               <a:t>df["_source_file"] = path.name</a:t>
             </a:r>
-            <a:endParaRPr lang="en-US" sz="950" dirty="0"/>
-          </a:p>
-          <a:p>
-            <a:pPr marL="0" indent="0">
-              <a:buNone/>
-            </a:pPr>
-            <a:r>
-              <a:rPr lang="en-US" sz="950" dirty="0">
-                <a:solidFill>
-                  <a:srgbClr val="F8FAFC"/>
-                </a:solidFill>
-                <a:latin typeface="Consolas" pitchFamily="34" charset="0"/>
-                <a:ea typeface="Consolas" pitchFamily="34" charset="-122"/>
-                <a:cs typeface="Consolas" pitchFamily="34" charset="-120"/>
+          </a:p>
+          <a:p>
+            <a:r>
+              <a:rPr sz="1000">
+                <a:solidFill>
+                  <a:srgbClr val="FFFFFF"/>
+                </a:solidFill>
               </a:rPr>
               <a:t>df["_source_row_number"] = range(1, len(df)+1)</a:t>
             </a:r>
-            <a:endParaRPr lang="en-US" sz="950" dirty="0"/>
-          </a:p>
-          <a:p>
-            <a:pPr marL="0" indent="0">
-              <a:buNone/>
-            </a:pPr>
-            <a:r>
-              <a:rPr lang="en-US" sz="950" dirty="0">
-                <a:solidFill>
-                  <a:srgbClr val="F8FAFC"/>
-                </a:solidFill>
-                <a:latin typeface="Consolas" pitchFamily="34" charset="0"/>
-                <a:ea typeface="Consolas" pitchFamily="34" charset="-122"/>
-                <a:cs typeface="Consolas" pitchFamily="34" charset="-120"/>
+          </a:p>
+          <a:p>
+            <a:r>
+              <a:rPr sz="1000">
+                <a:solidFill>
+                  <a:srgbClr val="FFFFFF"/>
+                </a:solidFill>
               </a:rPr>
               <a:t>df["_ingested_at_utc"] = now_utc</a:t>
             </a:r>
-            <a:endParaRPr lang="en-US" sz="950" dirty="0"/>
           </a:p>
         </p:txBody>
       </p:sp>
@@ -9274,20 +8769,44 @@
           </a:bodyPr>
           <a:lstStyle/>
           <a:p>
-            <a:pPr marL="0" indent="0">
-              <a:buNone/>
-            </a:pPr>
-            <a:r>
-              <a:rPr lang="en-US" sz="1230" dirty="0">
-                <a:solidFill>
-                  <a:srgbClr val="0B1F33"/>
-                </a:solidFill>
-              </a:rPr>
-              <a:t>• Todos os campos de origem foram carregados como texto.
-• A interpretação física do arquivo foi corrigida apenas quando necessário: TSV por tabulação; Glassdoor por pipe `|`.
-• As transformações semânticas ficaram exclusivamente no dbt/SQL.</a:t>
-            </a:r>
-            <a:endParaRPr lang="en-US" sz="1230" dirty="0"/>
+            <a:r>
+              <a:rPr sz="1000">
+                <a:solidFill>
+                  <a:srgbClr val="FFFFFF"/>
+                </a:solidFill>
+              </a:rPr>
+              <a:t>• Todos os campos de origem foram carregados como texto.</a:t>
+            </a:r>
+          </a:p>
+          <a:p>
+            <a:r>
+              <a:rPr sz="1000">
+                <a:solidFill>
+                  <a:srgbClr val="FFFFFF"/>
+                </a:solidFill>
+              </a:rPr>
+              <a:t>• A interpretação física do arquivo foi corrigida apenas quando comprovada: TSV por tabulação; Glassdoor por pipe `|`.</a:t>
+            </a:r>
+          </a:p>
+          <a:p>
+            <a:r>
+              <a:rPr sz="1000">
+                <a:solidFill>
+                  <a:srgbClr val="FFFFFF"/>
+                </a:solidFill>
+              </a:rPr>
+              <a:t>• Cabeçalhos Unicode problemáticos são normalizados tecnicamente por função reutilizável, sem alterar dados de negócio.</a:t>
+            </a:r>
+          </a:p>
+          <a:p>
+            <a:r>
+              <a:rPr sz="1000">
+                <a:solidFill>
+                  <a:srgbClr val="FFFFFF"/>
+                </a:solidFill>
+              </a:rPr>
+              <a:t>• As transformações semânticas permanecem no dbt/SQL.</a:t>
+            </a:r>
           </a:p>
         </p:txBody>
       </p:sp>
@@ -9878,112 +9397,75 @@
           </a:bodyPr>
           <a:lstStyle/>
           <a:p>
-            <a:pPr marL="0" indent="0">
-              <a:buNone/>
-            </a:pPr>
-            <a:r>
-              <a:rPr lang="en-US" sz="1100" dirty="0">
-                <a:solidFill>
-                  <a:srgbClr val="F8FAFC"/>
-                </a:solidFill>
-                <a:latin typeface="Consolas" pitchFamily="34" charset="0"/>
-                <a:ea typeface="Consolas" pitchFamily="34" charset="-122"/>
-                <a:cs typeface="Consolas" pitchFamily="34" charset="-120"/>
-              </a:rPr>
-              <a:t>Problemas observados:</a:t>
-            </a:r>
-            <a:endParaRPr lang="en-US" sz="1100" dirty="0"/>
-          </a:p>
-          <a:p>
-            <a:pPr marL="0" indent="0">
-              <a:buNone/>
-            </a:pPr>
-            <a:endParaRPr lang="en-US" sz="1100" dirty="0"/>
-          </a:p>
-          <a:p>
-            <a:pPr marL="0" indent="0">
-              <a:buNone/>
-            </a:pPr>
-            <a:r>
-              <a:rPr lang="en-US" sz="1100" dirty="0">
-                <a:solidFill>
-                  <a:srgbClr val="F8FAFC"/>
-                </a:solidFill>
-                <a:latin typeface="Consolas" pitchFamily="34" charset="0"/>
-                <a:ea typeface="Consolas" pitchFamily="34" charset="-122"/>
-                <a:cs typeface="Consolas" pitchFamily="34" charset="-120"/>
+            <a:r>
+              <a:rPr sz="1100">
+                <a:solidFill>
+                  <a:srgbClr val="FFFFFF"/>
+                </a:solidFill>
+              </a:rPr>
+              <a:t>Problemas observados e tratados:</a:t>
+            </a:r>
+          </a:p>
+          <a:p/>
+          <a:p>
+            <a:r>
+              <a:rPr sz="1100">
+                <a:solidFill>
+                  <a:srgbClr val="FFFFFF"/>
+                </a:solidFill>
               </a:rPr>
               <a:t>• Cabeçalhos Glassdoor fragmentados</a:t>
             </a:r>
-            <a:endParaRPr lang="en-US" sz="1100" dirty="0"/>
-          </a:p>
-          <a:p>
-            <a:pPr marL="0" indent="0">
-              <a:buNone/>
-            </a:pPr>
-            <a:r>
-              <a:rPr lang="en-US" sz="1100" dirty="0">
-                <a:solidFill>
-                  <a:srgbClr val="F8FAFC"/>
-                </a:solidFill>
-                <a:latin typeface="Consolas" pitchFamily="34" charset="0"/>
-                <a:ea typeface="Consolas" pitchFamily="34" charset="-122"/>
-                <a:cs typeface="Consolas" pitchFamily="34" charset="-120"/>
+          </a:p>
+          <a:p>
+            <a:r>
+              <a:rPr sz="1100">
+                <a:solidFill>
+                  <a:srgbClr val="FFFFFF"/>
+                </a:solidFill>
               </a:rPr>
               <a:t>• Caractere U+0096 em colunas de clientes</a:t>
             </a:r>
-            <a:endParaRPr lang="en-US" sz="1100" dirty="0"/>
-          </a:p>
-          <a:p>
-            <a:pPr marL="0" indent="0">
-              <a:buNone/>
-            </a:pPr>
-            <a:r>
-              <a:rPr lang="en-US" sz="1100" dirty="0">
-                <a:solidFill>
-                  <a:srgbClr val="F8FAFC"/>
-                </a:solidFill>
-                <a:latin typeface="Consolas" pitchFamily="34" charset="0"/>
-                <a:ea typeface="Consolas" pitchFamily="34" charset="-122"/>
-                <a:cs typeface="Consolas" pitchFamily="34" charset="-120"/>
+          </a:p>
+          <a:p>
+            <a:r>
+              <a:rPr sz="1100">
+                <a:solidFill>
+                  <a:srgbClr val="FFFFFF"/>
+                </a:solidFill>
+              </a:rPr>
+              <a:t>• CNPJs-base duplicados no enquadramento</a:t>
+            </a:r>
+          </a:p>
+          <a:p>
+            <a:r>
+              <a:rPr sz="1100">
+                <a:solidFill>
+                  <a:srgbClr val="FFFFFF"/>
+                </a:solidFill>
               </a:rPr>
               <a:t>• Coluna Unnamed: 14 vazia</a:t>
             </a:r>
-            <a:endParaRPr lang="en-US" sz="1100" dirty="0"/>
-          </a:p>
-          <a:p>
-            <a:pPr marL="0" indent="0">
-              <a:buNone/>
-            </a:pPr>
-            <a:r>
-              <a:rPr lang="en-US" sz="1100" dirty="0">
-                <a:solidFill>
-                  <a:srgbClr val="F8FAFC"/>
-                </a:solidFill>
-                <a:latin typeface="Consolas" pitchFamily="34" charset="0"/>
-                <a:ea typeface="Consolas" pitchFamily="34" charset="-122"/>
-                <a:cs typeface="Consolas" pitchFamily="34" charset="-120"/>
+          </a:p>
+          <a:p>
+            <a:r>
+              <a:rPr sz="1100">
+                <a:solidFill>
+                  <a:srgbClr val="FFFFFF"/>
+                </a:solidFill>
               </a:rPr>
               <a:t>• BOM UTF-8 em SQL gerado por PowerShell</a:t>
             </a:r>
-            <a:endParaRPr lang="en-US" sz="1100" dirty="0"/>
-          </a:p>
-          <a:p>
-            <a:pPr marL="0" indent="0">
-              <a:buNone/>
-            </a:pPr>
-            <a:r>
-              <a:rPr lang="en-US" sz="1100" dirty="0">
-                <a:solidFill>
-                  <a:srgbClr val="F8FAFC"/>
-                </a:solidFill>
-                <a:latin typeface="Consolas" pitchFamily="34" charset="0"/>
-                <a:ea typeface="Consolas" pitchFamily="34" charset="-122"/>
-                <a:cs typeface="Consolas" pitchFamily="34" charset="-120"/>
+          </a:p>
+          <a:p>
+            <a:r>
+              <a:rPr sz="1100">
+                <a:solidFill>
+                  <a:srgbClr val="FFFFFF"/>
+                </a:solidFill>
               </a:rPr>
               <a:t>• Aspas/acentuação em comandos psql</a:t>
             </a:r>
-            <a:endParaRPr lang="en-US" sz="1100" dirty="0"/>
           </a:p>
         </p:txBody>
       </p:sp>
@@ -10046,21 +9528,34 @@
           </a:bodyPr>
           <a:lstStyle/>
           <a:p>
-            <a:pPr marL="0" indent="0">
-              <a:buNone/>
-            </a:pPr>
-            <a:r>
-              <a:rPr lang="en-US" sz="1220" dirty="0">
-                <a:solidFill>
-                  <a:srgbClr val="0B1F33"/>
-                </a:solidFill>
-              </a:rPr>
-              <a:t>• Corrigir parsing físico na ingestão quando o delimitador real foi comprovado.
-• Preservar cabeçalhos problemáticos na RAW e normalizá-los somente na Trusted.
-• Excluir `Unnamed: 14` apenas após evidência de 100% vazio nas sete bases trimestrais.
-• Manter CNPJ como texto para preservar zeros à esquerda.</a:t>
-            </a:r>
-            <a:endParaRPr lang="en-US" sz="1220" dirty="0"/>
+            <a:r>
+              <a:rPr sz="1300"/>
+              <a:t>• Corrigir parsing físico na ingestão quando o delimitador real foi comprovado.</a:t>
+            </a:r>
+          </a:p>
+          <a:p>
+            <a:r>
+              <a:rPr sz="1300"/>
+              <a:t>• Normalizar cabeçalhos Unicode em `text_utils.py`, antes da persistência na RAW.</a:t>
+            </a:r>
+          </a:p>
+          <a:p>
+            <a:r>
+              <a:rPr sz="1300"/>
+              <a:t>• Deduplicar CNPJs na Trusted com regra determinística e aliases preservados.</a:t>
+            </a:r>
+          </a:p>
+          <a:p>
+            <a:r>
+              <a:rPr sz="1300"/>
+              <a:t>• Excluir `Unnamed: 14` apenas após evidência de 100% vazio.</a:t>
+            </a:r>
+          </a:p>
+          <a:p>
+            <a:r>
+              <a:rPr sz="1300"/>
+              <a:t>• Manter CNPJ como texto para preservar zeros à esquerda.</a:t>
+            </a:r>
           </a:p>
         </p:txBody>
       </p:sp>
@@ -10182,21 +9677,14 @@
           <a:bodyPr wrap="square" lIns="0" tIns="0" rIns="0" bIns="0" rtlCol="0" anchor="ctr"/>
           <a:lstStyle/>
           <a:p>
-            <a:pPr marL="0" indent="0">
-              <a:buNone/>
-            </a:pPr>
-            <a:r>
-              <a:rPr lang="en-US" sz="2400" b="1" dirty="0">
-                <a:solidFill>
-                  <a:srgbClr val="0B1F33"/>
-                </a:solidFill>
-                <a:latin typeface="Aptos Display" pitchFamily="34" charset="0"/>
-                <a:ea typeface="Aptos Display" pitchFamily="34" charset="-122"/>
-                <a:cs typeface="Aptos Display" pitchFamily="34" charset="-120"/>
-              </a:rPr>
-              <a:t>Camada Trusted: tratamento, tipagem e padronização via dbt</a:t>
-            </a:r>
-            <a:endParaRPr lang="en-US" sz="2400" dirty="0"/>
+            <a:r>
+              <a:rPr sz="2800" b="1">
+                <a:solidFill>
+                  <a:srgbClr val="0A1C30"/>
+                </a:solidFill>
+              </a:rPr>
+              <a:t>Camada Trusted: tratamento via dbt</a:t>
+            </a:r>
           </a:p>
         </p:txBody>
       </p:sp>
@@ -10221,18 +9709,14 @@
           <a:bodyPr wrap="square" lIns="0" tIns="0" rIns="0" bIns="0" rtlCol="0" anchor="ctr"/>
           <a:lstStyle/>
           <a:p>
-            <a:pPr marL="0" indent="0">
-              <a:buNone/>
-            </a:pPr>
-            <a:r>
-              <a:rPr lang="en-US" sz="950" dirty="0">
-                <a:solidFill>
-                  <a:srgbClr val="667085"/>
-                </a:solidFill>
-              </a:rPr>
-              <a:t>Três modelos materializados como tabelas no schema trusted.</a:t>
-            </a:r>
-            <a:endParaRPr lang="en-US" sz="950" dirty="0"/>
+            <a:r>
+              <a:rPr sz="1800">
+                <a:solidFill>
+                  <a:srgbClr val="000000"/>
+                </a:solidFill>
+              </a:rPr>
+              <a:t>Quatro modelos materializados e uma base ephemeral organizam a camada trusted.</a:t>
+            </a:r>
           </a:p>
         </p:txBody>
       </p:sp>
@@ -10385,32 +9869,16 @@
           <a:bodyPr wrap="square" lIns="635" tIns="635" rIns="635" bIns="635" rtlCol="0" anchor="ctr"/>
           <a:lstStyle/>
           <a:p>
-            <a:pPr marL="0" indent="0" algn="ctr">
-              <a:buNone/>
-            </a:pPr>
-            <a:r>
-              <a:rPr lang="en-US" sz="1350" b="1" dirty="0">
-                <a:solidFill>
-                  <a:srgbClr val="00A6A6"/>
-                </a:solidFill>
-              </a:rPr>
+            <a:r>
+              <a:rPr sz="1600"/>
               <a:t>trusted.enquadramento</a:t>
             </a:r>
-            <a:endParaRPr lang="en-US" sz="1350" dirty="0"/>
-          </a:p>
-          <a:p>
-            <a:pPr marL="0" indent="0" algn="ctr">
-              <a:buNone/>
-            </a:pPr>
-            <a:r>
-              <a:rPr lang="en-US" sz="1350" b="1" dirty="0">
-                <a:solidFill>
-                  <a:srgbClr val="00A6A6"/>
-                </a:solidFill>
-              </a:rPr>
-              <a:t>1.474 linhas</a:t>
-            </a:r>
-            <a:endParaRPr lang="en-US" sz="1350" dirty="0"/>
+          </a:p>
+          <a:p>
+            <a:r>
+              <a:rPr sz="1600"/>
+              <a:t>1.459 linhas</a:t>
+            </a:r>
           </a:p>
         </p:txBody>
       </p:sp>
@@ -10497,32 +9965,16 @@
           <a:bodyPr wrap="square" lIns="635" tIns="635" rIns="635" bIns="635" rtlCol="0" anchor="ctr"/>
           <a:lstStyle/>
           <a:p>
-            <a:pPr marL="0" indent="0" algn="ctr">
-              <a:buNone/>
-            </a:pPr>
-            <a:r>
-              <a:rPr lang="en-US" sz="1250" b="1" dirty="0">
-                <a:solidFill>
-                  <a:srgbClr val="F59E0B"/>
-                </a:solidFill>
-              </a:rPr>
-              <a:t>SQL/dbt</a:t>
-            </a:r>
-            <a:endParaRPr lang="en-US" sz="1250" dirty="0"/>
-          </a:p>
-          <a:p>
-            <a:pPr marL="0" indent="0" algn="ctr">
-              <a:buNone/>
-            </a:pPr>
-            <a:r>
-              <a:rPr lang="en-US" sz="1250" b="1" dirty="0">
-                <a:solidFill>
-                  <a:srgbClr val="F59E0B"/>
-                </a:solidFill>
-              </a:rPr>
-              <a:t>100% transformação</a:t>
-            </a:r>
-            <a:endParaRPr lang="en-US" sz="1250" dirty="0"/>
+            <a:r>
+              <a:rPr sz="1600"/>
+              <a:t>trusted.aliases</a:t>
+            </a:r>
+          </a:p>
+          <a:p>
+            <a:r>
+              <a:rPr sz="1600"/>
+              <a:t>1.474 linhas</a:t>
+            </a:r>
           </a:p>
         </p:txBody>
       </p:sp>
@@ -10555,118 +10007,87 @@
           </a:bodyPr>
           <a:lstStyle/>
           <a:p>
-            <a:pPr marL="0" indent="0">
-              <a:buNone/>
-            </a:pPr>
-            <a:r>
-              <a:rPr lang="en-US" sz="960" dirty="0">
-                <a:solidFill>
-                  <a:srgbClr val="F8FAFC"/>
-                </a:solidFill>
-                <a:latin typeface="Consolas" pitchFamily="34" charset="0"/>
-                <a:ea typeface="Consolas" pitchFamily="34" charset="-122"/>
-                <a:cs typeface="Consolas" pitchFamily="34" charset="-120"/>
-              </a:rPr>
-              <a:t>-- Exemplo 1: trimestre</a:t>
-            </a:r>
-            <a:endParaRPr lang="en-US" sz="960" dirty="0"/>
-          </a:p>
-          <a:p>
-            <a:pPr marL="0" indent="0">
-              <a:buNone/>
-            </a:pPr>
-            <a:r>
-              <a:rPr lang="en-US" sz="960" dirty="0">
-                <a:solidFill>
-                  <a:srgbClr val="F8FAFC"/>
-                </a:solidFill>
-                <a:latin typeface="Consolas" pitchFamily="34" charset="0"/>
-                <a:ea typeface="Consolas" pitchFamily="34" charset="-122"/>
-                <a:cs typeface="Consolas" pitchFamily="34" charset="-120"/>
+            <a:r>
+              <a:rPr sz="1000">
+                <a:solidFill>
+                  <a:srgbClr val="FFFFFF"/>
+                </a:solidFill>
+              </a:rPr>
+              <a:t>-- trimestre</a:t>
+            </a:r>
+          </a:p>
+          <a:p>
+            <a:r>
+              <a:rPr sz="1000">
+                <a:solidFill>
+                  <a:srgbClr val="FFFFFF"/>
+                </a:solidFill>
               </a:rPr>
               <a:t>regexp_replace(trim("Trimestre"), '[^0-9]', '', 'g')::integer</a:t>
             </a:r>
-            <a:endParaRPr lang="en-US" sz="960" dirty="0"/>
-          </a:p>
-          <a:p>
-            <a:pPr marL="0" indent="0">
-              <a:buNone/>
-            </a:pPr>
-            <a:endParaRPr lang="en-US" sz="960" dirty="0"/>
-          </a:p>
-          <a:p>
-            <a:pPr marL="0" indent="0">
-              <a:buNone/>
-            </a:pPr>
-            <a:r>
-              <a:rPr lang="en-US" sz="960" dirty="0">
-                <a:solidFill>
-                  <a:srgbClr val="F8FAFC"/>
-                </a:solidFill>
-                <a:latin typeface="Consolas" pitchFamily="34" charset="0"/>
-                <a:ea typeface="Consolas" pitchFamily="34" charset="-122"/>
-                <a:cs typeface="Consolas" pitchFamily="34" charset="-120"/>
-              </a:rPr>
-              <a:t>-- Exemplo 2: índice decimal</a:t>
-            </a:r>
-            <a:endParaRPr lang="en-US" sz="960" dirty="0"/>
-          </a:p>
-          <a:p>
-            <a:pPr marL="0" indent="0">
-              <a:buNone/>
-            </a:pPr>
-            <a:r>
-              <a:rPr lang="en-US" sz="960" dirty="0">
-                <a:solidFill>
-                  <a:srgbClr val="F8FAFC"/>
-                </a:solidFill>
-                <a:latin typeface="Consolas" pitchFamily="34" charset="0"/>
-                <a:ea typeface="Consolas" pitchFamily="34" charset="-122"/>
-                <a:cs typeface="Consolas" pitchFamily="34" charset="-120"/>
+          </a:p>
+          <a:p/>
+          <a:p>
+            <a:r>
+              <a:rPr sz="1000">
+                <a:solidFill>
+                  <a:srgbClr val="FFFFFF"/>
+                </a:solidFill>
+              </a:rPr>
+              <a:t>-- índice decimal</a:t>
+            </a:r>
+          </a:p>
+          <a:p>
+            <a:r>
+              <a:rPr sz="1000">
+                <a:solidFill>
+                  <a:srgbClr val="FFFFFF"/>
+                </a:solidFill>
               </a:rPr>
               <a:t>replace(trim("Índice"), ',', '.')::numeric(18,4)</a:t>
             </a:r>
-            <a:endParaRPr lang="en-US" sz="960" dirty="0"/>
-          </a:p>
-          <a:p>
-            <a:pPr marL="0" indent="0">
-              <a:buNone/>
-            </a:pPr>
-            <a:endParaRPr lang="en-US" sz="960" dirty="0"/>
-          </a:p>
-          <a:p>
-            <a:pPr marL="0" indent="0">
-              <a:buNone/>
-            </a:pPr>
-            <a:r>
-              <a:rPr lang="en-US" sz="960" dirty="0">
-                <a:solidFill>
-                  <a:srgbClr val="F8FAFC"/>
-                </a:solidFill>
-                <a:latin typeface="Consolas" pitchFamily="34" charset="0"/>
-                <a:ea typeface="Consolas" pitchFamily="34" charset="-122"/>
-                <a:cs typeface="Consolas" pitchFamily="34" charset="-120"/>
-              </a:rPr>
-              <a:t>-- Exemplo 3: CNPJ-base</a:t>
-            </a:r>
-            <a:endParaRPr lang="en-US" sz="960" dirty="0"/>
-          </a:p>
-          <a:p>
-            <a:pPr marL="0" indent="0">
-              <a:buNone/>
-            </a:pPr>
-            <a:r>
-              <a:rPr lang="en-US" sz="960" dirty="0">
-                <a:solidFill>
-                  <a:srgbClr val="F8FAFC"/>
-                </a:solidFill>
-                <a:latin typeface="Consolas" pitchFamily="34" charset="0"/>
-                <a:ea typeface="Consolas" pitchFamily="34" charset="-122"/>
-                <a:cs typeface="Consolas" pitchFamily="34" charset="-120"/>
+          </a:p>
+          <a:p/>
+          <a:p>
+            <a:r>
+              <a:rPr sz="1000">
+                <a:solidFill>
+                  <a:srgbClr val="FFFFFF"/>
+                </a:solidFill>
+              </a:rPr>
+              <a:t>-- CNPJ-base canônico</a:t>
+            </a:r>
+          </a:p>
+          <a:p>
+            <a:r>
+              <a:rPr sz="1000">
+                <a:solidFill>
+                  <a:srgbClr val="FFFFFF"/>
+                </a:solidFill>
               </a:rPr>
               <a:t>lpad(trim("CNPJ"), 8, '0') as cnpj_if</a:t>
             </a:r>
-            <a:endParaRPr lang="en-US" sz="960" dirty="0"/>
+          </a:p>
+          <a:p/>
+          <a:p>
+            <a:r>
+              <a:rPr sz="1000">
+                <a:solidFill>
+                  <a:srgbClr val="FFFFFF"/>
+                </a:solidFill>
+              </a:rPr>
+              <a:t>-- unicidade</a:t>
+            </a:r>
+          </a:p>
+          <a:p>
+            <a:r>
+              <a:rPr sz="1000">
+                <a:solidFill>
+                  <a:srgbClr val="FFFFFF"/>
+                </a:solidFill>
+              </a:rPr>
+              <a:t>row_number() over (partition by cnpj_if order by ...) = 1</a:t>
+            </a:r>
           </a:p>
         </p:txBody>
       </p:sp>
@@ -10693,21 +10114,34 @@
           </a:bodyPr>
           <a:lstStyle/>
           <a:p>
-            <a:pPr marL="0" indent="0">
-              <a:buNone/>
-            </a:pPr>
-            <a:r>
-              <a:rPr lang="en-US" sz="1220" dirty="0">
-                <a:solidFill>
-                  <a:srgbClr val="0B1F33"/>
-                </a:solidFill>
-              </a:rPr>
-              <a:t>• Reclamações: consolidação de sete trimestres por UNION ALL.
-• Enquadramento: CNPJ-base normalizado para oito dígitos.
-• Glassdoor: consolidação de match e match_less com indicadores de origem.
-• Metadados técnicos preservados para rastreabilidade.</a:t>
-            </a:r>
-            <a:endParaRPr lang="en-US" sz="1220" dirty="0"/>
+            <a:r>
+              <a:rPr sz="1200"/>
+              <a:t>• Reclamações: consolidação de sete trimestres por UNION ALL.</a:t>
+            </a:r>
+          </a:p>
+          <a:p>
+            <a:r>
+              <a:rPr sz="1200"/>
+              <a:t>• Enquadramento: CNPJ-base normalizado, deduplicado e testado como único.</a:t>
+            </a:r>
+          </a:p>
+          <a:p>
+            <a:r>
+              <a:rPr sz="1200"/>
+              <a:t>• Aliases: nomes alternativos preservados para matching com Glassdoor.</a:t>
+            </a:r>
+          </a:p>
+          <a:p>
+            <a:r>
+              <a:rPr sz="1200"/>
+              <a:t>• Glassdoor: consolidação de match e match_less com indicadores de origem.</a:t>
+            </a:r>
+          </a:p>
+          <a:p>
+            <a:r>
+              <a:rPr sz="1200"/>
+              <a:t>• Metadados técnicos preservados para rastreabilidade.</a:t>
+            </a:r>
           </a:p>
         </p:txBody>
       </p:sp>
@@ -10865,21 +10299,9 @@
           <a:bodyPr wrap="square" lIns="0" tIns="0" rIns="0" bIns="0" rtlCol="0" anchor="ctr"/>
           <a:lstStyle/>
           <a:p>
-            <a:pPr marL="0" indent="0">
-              <a:buNone/>
-            </a:pPr>
-            <a:r>
-              <a:rPr lang="en-US" sz="2400" b="1" dirty="0">
-                <a:solidFill>
-                  <a:srgbClr val="0B1F33"/>
-                </a:solidFill>
-                <a:latin typeface="Aptos Display" pitchFamily="34" charset="0"/>
-                <a:ea typeface="Aptos Display" pitchFamily="34" charset="-122"/>
-                <a:cs typeface="Aptos Display" pitchFamily="34" charset="-120"/>
-              </a:rPr>
-              <a:t>Camada Delivery: integração com controle de cardinalidade</a:t>
-            </a:r>
-            <a:endParaRPr lang="en-US" sz="2400" dirty="0"/>
+            <a:r>
+              <a:t>Camada Delivery: integração via modelos dbt intermediários</a:t>
+            </a:r>
           </a:p>
         </p:txBody>
       </p:sp>
@@ -10904,18 +10326,9 @@
           <a:bodyPr wrap="square" lIns="0" tIns="0" rIns="0" bIns="0" rtlCol="0" anchor="ctr"/>
           <a:lstStyle/>
           <a:p>
-            <a:pPr marL="0" indent="0">
-              <a:buNone/>
-            </a:pPr>
-            <a:r>
-              <a:rPr lang="en-US" sz="950" dirty="0">
-                <a:solidFill>
-                  <a:srgbClr val="667085"/>
-                </a:solidFill>
-              </a:rPr>
-              <a:t>A tabela final enriquece as reclamações sem alterar a granularidade original.</a:t>
-            </a:r>
-            <a:endParaRPr lang="en-US" sz="950" dirty="0"/>
+            <a:r>
+              <a:t>A tabela final consome modelos `intermediate` e preserva a granularidade original.</a:t>
+            </a:r>
           </a:p>
         </p:txBody>
       </p:sp>
@@ -11100,32 +10513,16 @@
           <a:bodyPr wrap="square" lIns="635" tIns="635" rIns="635" bIns="635" rtlCol="0" anchor="ctr"/>
           <a:lstStyle/>
           <a:p>
-            <a:pPr marL="0" indent="0" algn="ctr">
-              <a:buNone/>
-            </a:pPr>
-            <a:r>
-              <a:rPr lang="en-US" sz="1200" b="1" dirty="0">
-                <a:solidFill>
-                  <a:srgbClr val="00A6A6"/>
-                </a:solidFill>
-              </a:rPr>
+            <a:r>
+              <a:rPr sz="1400"/>
               <a:t>enquadramento</a:t>
             </a:r>
-            <a:endParaRPr lang="en-US" sz="1200" dirty="0"/>
-          </a:p>
-          <a:p>
-            <a:pPr marL="0" indent="0" algn="ctr">
-              <a:buNone/>
-            </a:pPr>
-            <a:r>
-              <a:rPr lang="en-US" sz="1200" b="1" dirty="0">
-                <a:solidFill>
-                  <a:srgbClr val="00A6A6"/>
-                </a:solidFill>
-              </a:rPr>
-              <a:t>canônico por CNPJ</a:t>
-            </a:r>
-            <a:endParaRPr lang="en-US" sz="1200" dirty="0"/>
+          </a:p>
+          <a:p>
+            <a:r>
+              <a:rPr sz="1400"/>
+              <a:t>canônico</a:t>
+            </a:r>
           </a:p>
         </p:txBody>
       </p:sp>
@@ -11156,32 +10553,16 @@
           <a:bodyPr wrap="square" lIns="635" tIns="635" rIns="635" bIns="635" rtlCol="0" anchor="ctr"/>
           <a:lstStyle/>
           <a:p>
-            <a:pPr marL="0" indent="0" algn="ctr">
-              <a:buNone/>
-            </a:pPr>
-            <a:r>
-              <a:rPr lang="en-US" sz="1150" b="1" dirty="0">
-                <a:solidFill>
-                  <a:srgbClr val="6D28D9"/>
-                </a:solidFill>
-              </a:rPr>
-              <a:t>aliases</a:t>
-            </a:r>
-            <a:endParaRPr lang="en-US" sz="1150" dirty="0"/>
-          </a:p>
-          <a:p>
-            <a:pPr marL="0" indent="0" algn="ctr">
-              <a:buNone/>
-            </a:pPr>
-            <a:r>
-              <a:rPr lang="en-US" sz="1150" b="1" dirty="0">
-                <a:solidFill>
-                  <a:srgbClr val="6D28D9"/>
-                </a:solidFill>
-              </a:rPr>
-              <a:t>para localizar Glassdoor</a:t>
-            </a:r>
-            <a:endParaRPr lang="en-US" sz="1150" dirty="0"/>
+            <a:r>
+              <a:rPr sz="1400"/>
+              <a:t>intermediate</a:t>
+            </a:r>
+          </a:p>
+          <a:p>
+            <a:r>
+              <a:rPr sz="1400"/>
+              <a:t>normalização</a:t>
+            </a:r>
           </a:p>
         </p:txBody>
       </p:sp>
@@ -11244,32 +10625,16 @@
           <a:bodyPr wrap="square" lIns="635" tIns="635" rIns="635" bIns="635" rtlCol="0" anchor="ctr"/>
           <a:lstStyle/>
           <a:p>
-            <a:pPr marL="0" indent="0" algn="ctr">
-              <a:buNone/>
-            </a:pPr>
-            <a:r>
-              <a:rPr lang="en-US" sz="1250" b="1" dirty="0">
-                <a:solidFill>
-                  <a:srgbClr val="2E7D32"/>
-                </a:solidFill>
-              </a:rPr>
+            <a:r>
+              <a:rPr sz="1400"/>
               <a:t>Glassdoor</a:t>
             </a:r>
-            <a:endParaRPr lang="en-US" sz="1250" dirty="0"/>
-          </a:p>
-          <a:p>
-            <a:pPr marL="0" indent="0" algn="ctr">
-              <a:buNone/>
-            </a:pPr>
-            <a:r>
-              <a:rPr lang="en-US" sz="1250" b="1" dirty="0">
-                <a:solidFill>
-                  <a:srgbClr val="2E7D32"/>
-                </a:solidFill>
-              </a:rPr>
-              <a:t>rankeado</a:t>
-            </a:r>
-            <a:endParaRPr lang="en-US" sz="1250" dirty="0"/>
+          </a:p>
+          <a:p>
+            <a:r>
+              <a:rPr sz="1400"/>
+              <a:t>por nome/CNPJ</a:t>
+            </a:r>
           </a:p>
         </p:txBody>
       </p:sp>
@@ -11363,90 +10728,14 @@
       </p:sp>
       <p:sp>
         <p:nvSpPr>
-          <p:cNvPr id="14" name="Text 12"/>
-          <p:cNvSpPr/>
-          <p:nvPr/>
-        </p:nvSpPr>
-        <p:spPr>
-          <a:xfrm>
-            <a:off x="868680" y="3063240"/>
-            <a:ext cx="3200400" cy="256032"/>
-          </a:xfrm>
-          <a:prstGeom prst="rect">
-            <a:avLst/>
-          </a:prstGeom>
-          <a:noFill/>
-          <a:ln/>
-        </p:spPr>
-        <p:txBody>
-          <a:bodyPr wrap="square" lIns="0" tIns="0" rIns="0" bIns="0" rtlCol="0" anchor="ctr"/>
-          <a:lstStyle/>
-          <a:p>
-            <a:pPr marL="0" indent="0">
-              <a:buNone/>
-            </a:pPr>
-            <a:r>
-              <a:rPr lang="en-US" sz="1400" b="1" dirty="0">
-                <a:solidFill>
-                  <a:srgbClr val="0B1F33"/>
-                </a:solidFill>
-              </a:rPr>
-              <a:t>Regras de desempate</a:t>
-            </a:r>
-            <a:endParaRPr lang="en-US" sz="1400" dirty="0"/>
-          </a:p>
-        </p:txBody>
-      </p:sp>
-      <p:sp>
-        <p:nvSpPr>
-          <p:cNvPr id="15" name="Text 13"/>
-          <p:cNvSpPr/>
-          <p:nvPr/>
-        </p:nvSpPr>
-        <p:spPr>
-          <a:xfrm>
-            <a:off x="868680" y="3474720"/>
-            <a:ext cx="5029200" cy="1508760"/>
-          </a:xfrm>
-          <a:prstGeom prst="rect">
-            <a:avLst/>
-          </a:prstGeom>
-          <a:noFill/>
-          <a:ln/>
-        </p:spPr>
-        <p:txBody>
-          <a:bodyPr wrap="square" lIns="635" tIns="635" rIns="635" bIns="635" rtlCol="0" anchor="t">
-            <a:normAutofit/>
-          </a:bodyPr>
-          <a:lstStyle/>
-          <a:p>
-            <a:pPr marL="0" indent="0">
-              <a:buNone/>
-            </a:pPr>
-            <a:r>
-              <a:rPr lang="en-US" sz="1210" dirty="0">
-                <a:solidFill>
-                  <a:srgbClr val="0B1F33"/>
-                </a:solidFill>
-              </a:rPr>
-              <a:t>• Enquadramento: preferir sufixo `- PRUDENCIAL`; depois menor linha de origem.
-• Glassdoor: maior match_percent; depois `match`; depois reviews_count; depois nome.
-• Reclamações sem CNPJ: comparar nome normalizado após remover `(conglomerado)`.</a:t>
-            </a:r>
-            <a:endParaRPr lang="en-US" sz="1210" dirty="0"/>
-          </a:p>
-        </p:txBody>
-      </p:sp>
-      <p:sp>
-        <p:nvSpPr>
           <p:cNvPr id="16" name="Text 14"/>
           <p:cNvSpPr/>
           <p:nvPr/>
         </p:nvSpPr>
         <p:spPr>
           <a:xfrm>
-            <a:off x="6309360" y="3017520"/>
-            <a:ext cx="4937760" cy="1554480"/>
+            <a:off x="5577840" y="2743200"/>
+            <a:ext cx="4937760" cy="1463040"/>
           </a:xfrm>
           <a:prstGeom prst="rect">
             <a:avLst/>
@@ -11461,111 +10750,89 @@
           </a:ln>
         </p:spPr>
         <p:txBody>
-          <a:bodyPr wrap="square" lIns="1524" tIns="1524" rIns="1524" bIns="1524" rtlCol="0" anchor="ctr">
+          <a:bodyPr wrap="square" lIns="76200" tIns="50800" rIns="1524" bIns="1524" rtlCol="0" anchor="ctr">
             <a:normAutofit/>
           </a:bodyPr>
           <a:lstStyle/>
           <a:p>
-            <a:pPr marL="0" indent="0">
-              <a:buNone/>
-            </a:pPr>
-            <a:r>
-              <a:rPr lang="en-US" sz="960" dirty="0">
-                <a:solidFill>
-                  <a:srgbClr val="F8FAFC"/>
-                </a:solidFill>
-                <a:latin typeface="Consolas" pitchFamily="34" charset="0"/>
-                <a:ea typeface="Consolas" pitchFamily="34" charset="-122"/>
-                <a:cs typeface="Consolas" pitchFamily="34" charset="-120"/>
-              </a:rPr>
-              <a:t>row_number() over (</a:t>
-            </a:r>
-            <a:endParaRPr lang="en-US" sz="960" dirty="0"/>
-          </a:p>
-          <a:p>
-            <a:pPr marL="0" indent="0">
-              <a:buNone/>
-            </a:pPr>
-            <a:r>
-              <a:rPr lang="en-US" sz="960" dirty="0">
-                <a:solidFill>
-                  <a:srgbClr val="F8FAFC"/>
-                </a:solidFill>
-                <a:latin typeface="Consolas" pitchFamily="34" charset="0"/>
-                <a:ea typeface="Consolas" pitchFamily="34" charset="-122"/>
-                <a:cs typeface="Consolas" pitchFamily="34" charset="-120"/>
-              </a:rPr>
-              <a:t>  partition by cnpj_if</a:t>
-            </a:r>
-            <a:endParaRPr lang="en-US" sz="960" dirty="0"/>
-          </a:p>
-          <a:p>
-            <a:pPr marL="0" indent="0">
-              <a:buNone/>
-            </a:pPr>
-            <a:r>
-              <a:rPr lang="en-US" sz="960" dirty="0">
-                <a:solidFill>
-                  <a:srgbClr val="F8FAFC"/>
-                </a:solidFill>
-                <a:latin typeface="Consolas" pitchFamily="34" charset="0"/>
-                <a:ea typeface="Consolas" pitchFamily="34" charset="-122"/>
-                <a:cs typeface="Consolas" pitchFamily="34" charset="-120"/>
-              </a:rPr>
-              <a:t>  order by match_percent desc,</a:t>
-            </a:r>
-            <a:endParaRPr lang="en-US" sz="960" dirty="0"/>
-          </a:p>
-          <a:p>
-            <a:pPr marL="0" indent="0">
-              <a:buNone/>
-            </a:pPr>
-            <a:r>
-              <a:rPr lang="en-US" sz="960" dirty="0">
-                <a:solidFill>
-                  <a:srgbClr val="F8FAFC"/>
-                </a:solidFill>
-                <a:latin typeface="Consolas" pitchFamily="34" charset="0"/>
-                <a:ea typeface="Consolas" pitchFamily="34" charset="-122"/>
-                <a:cs typeface="Consolas" pitchFamily="34" charset="-120"/>
-              </a:rPr>
-              <a:t>           case when tipo_match = 'match' then 1 else 2 end,</a:t>
-            </a:r>
-            <a:endParaRPr lang="en-US" sz="960" dirty="0"/>
-          </a:p>
-          <a:p>
-            <a:pPr marL="0" indent="0">
-              <a:buNone/>
-            </a:pPr>
-            <a:r>
-              <a:rPr lang="en-US" sz="960" dirty="0">
-                <a:solidFill>
-                  <a:srgbClr val="F8FAFC"/>
-                </a:solidFill>
-                <a:latin typeface="Consolas" pitchFamily="34" charset="0"/>
-                <a:ea typeface="Consolas" pitchFamily="34" charset="-122"/>
-                <a:cs typeface="Consolas" pitchFamily="34" charset="-120"/>
-              </a:rPr>
-              <a:t>           reviews_count desc, employer_name</a:t>
-            </a:r>
-            <a:endParaRPr lang="en-US" sz="960" dirty="0"/>
-          </a:p>
-          <a:p>
-            <a:pPr marL="0" indent="0">
-              <a:buNone/>
-            </a:pPr>
-            <a:r>
-              <a:rPr lang="en-US" sz="960" dirty="0">
-                <a:solidFill>
-                  <a:srgbClr val="F8FAFC"/>
-                </a:solidFill>
-                <a:latin typeface="Consolas" pitchFamily="34" charset="0"/>
-                <a:ea typeface="Consolas" pitchFamily="34" charset="-122"/>
-                <a:cs typeface="Consolas" pitchFamily="34" charset="-120"/>
-              </a:rPr>
-              <a:t>) as rn</a:t>
-            </a:r>
-            <a:endParaRPr lang="en-US" sz="960" dirty="0"/>
+            <a:r>
+              <a:rPr sz="800">
+                <a:solidFill>
+                  <a:srgbClr val="FFFFFF"/>
+                </a:solidFill>
+              </a:rPr>
+              <a:t>from {{ ref('int_reclamacoes_normalizadas') }} r</a:t>
+            </a:r>
+          </a:p>
+          <a:p>
+            <a:r>
+              <a:rPr sz="800">
+                <a:solidFill>
+                  <a:srgbClr val="FFFFFF"/>
+                </a:solidFill>
+              </a:rPr>
+              <a:t>left join {{ ref('enquadramento') }} e</a:t>
+            </a:r>
+          </a:p>
+          <a:p>
+            <a:r>
+              <a:rPr sz="800">
+                <a:solidFill>
+                  <a:srgbClr val="FFFFFF"/>
+                </a:solidFill>
+              </a:rPr>
+              <a:t>  on r.cnpj_if = e.cnpj_if</a:t>
+            </a:r>
+          </a:p>
+          <a:p>
+            <a:r>
+              <a:rPr sz="800">
+                <a:solidFill>
+                  <a:srgbClr val="FFFFFF"/>
+                </a:solidFill>
+              </a:rPr>
+              <a:t>left join {{ ref('int_glassdoor_por_cnpj') }} gc</a:t>
+            </a:r>
+          </a:p>
+          <a:p>
+            <a:r>
+              <a:rPr sz="800">
+                <a:solidFill>
+                  <a:srgbClr val="FFFFFF"/>
+                </a:solidFill>
+              </a:rPr>
+              <a:t>  on r.cnpj_if = gc.cnpj_if</a:t>
+            </a:r>
+          </a:p>
+          <a:p>
+            <a:r>
+              <a:rPr sz="800">
+                <a:solidFill>
+                  <a:srgbClr val="FFFFFF"/>
+                </a:solidFill>
+              </a:rPr>
+              <a:t>left join {{ ref('int_glassdoor_por_nome') }} gn</a:t>
+            </a:r>
+          </a:p>
+          <a:p>
+            <a:r>
+              <a:rPr sz="800">
+                <a:solidFill>
+                  <a:srgbClr val="FFFFFF"/>
+                </a:solidFill>
+              </a:rPr>
+              <a:t>  on r.cnpj_if is null</a:t>
+            </a:r>
+          </a:p>
+          <a:p>
+            <a:r>
+              <a:rPr sz="800">
+                <a:solidFill>
+                  <a:srgbClr val="FFFFFF"/>
+                </a:solidFill>
+              </a:rPr>
+              <a:t> and r.instituicao_nome_normalizado = gn.nome_normalizado</a:t>
+            </a:r>
           </a:p>
         </p:txBody>
       </p:sp>
@@ -11674,6 +10941,116 @@
               <a:t>07</a:t>
             </a:r>
             <a:endParaRPr lang="en-US" sz="860" dirty="0"/>
+          </a:p>
+        </p:txBody>
+      </p:sp>
+      <p:sp>
+        <p:nvSpPr>
+          <p:cNvPr id="20" name="TextBox 19"/>
+          <p:cNvSpPr txBox="1"/>
+          <p:nvPr/>
+        </p:nvSpPr>
+        <p:spPr>
+          <a:xfrm>
+            <a:off x="777240" y="2514600"/>
+            <a:ext cx="4251960" cy="1783080"/>
+          </a:xfrm>
+          <a:prstGeom prst="rect">
+            <a:avLst/>
+          </a:prstGeom>
+          <a:noFill/>
+        </p:spPr>
+        <p:txBody>
+          <a:bodyPr wrap="none">
+            <a:spAutoFit/>
+          </a:bodyPr>
+          <a:lstStyle/>
+          <a:p>
+            <a:r>
+              <a:rPr b="1" sz="1400">
+                <a:solidFill>
+                  <a:srgbClr val="000000"/>
+                </a:solidFill>
+              </a:rPr>
+              <a:t>Modelos intermediate (ephemeral)</a:t>
+            </a:r>
+          </a:p>
+          <a:p>
+            <a:pPr/>
+            <a:r>
+              <a:rPr sz="1000">
+                <a:solidFill>
+                  <a:srgbClr val="000000"/>
+                </a:solidFill>
+              </a:rPr>
+              <a:t>int_reclamacoes_normalizadas: normaliza instituição financeira</a:t>
+            </a:r>
+          </a:p>
+          <a:p>
+            <a:pPr/>
+            <a:r>
+              <a:rPr sz="1000">
+                <a:solidFill>
+                  <a:srgbClr val="000000"/>
+                </a:solidFill>
+              </a:rPr>
+              <a:t>int_glassdoor_normalizado: aplica macro textual</a:t>
+            </a:r>
+          </a:p>
+          <a:p>
+            <a:pPr/>
+            <a:r>
+              <a:rPr sz="1000">
+                <a:solidFill>
+                  <a:srgbClr val="000000"/>
+                </a:solidFill>
+              </a:rPr>
+              <a:t>int_glassdoor_por_nome: seleciona 1 registro por nome</a:t>
+            </a:r>
+          </a:p>
+          <a:p>
+            <a:pPr/>
+            <a:r>
+              <a:rPr sz="1000">
+                <a:solidFill>
+                  <a:srgbClr val="000000"/>
+                </a:solidFill>
+              </a:rPr>
+              <a:t>int_glassdoor_por_cnpj: consolida aliases e CNPJ direto</a:t>
+            </a:r>
+          </a:p>
+        </p:txBody>
+      </p:sp>
+      <p:sp>
+        <p:nvSpPr>
+          <p:cNvPr id="21" name="TextBox 20"/>
+          <p:cNvSpPr txBox="1"/>
+          <p:nvPr/>
+        </p:nvSpPr>
+        <p:spPr>
+          <a:xfrm>
+            <a:off x="5577840" y="2468880"/>
+            <a:ext cx="4937760" cy="274320"/>
+          </a:xfrm>
+          <a:prstGeom prst="rect">
+            <a:avLst/>
+          </a:prstGeom>
+          <a:noFill/>
+        </p:spPr>
+        <p:txBody>
+          <a:bodyPr wrap="none">
+            <a:spAutoFit/>
+          </a:bodyPr>
+          <a:lstStyle/>
+          <a:p>
+            <a:r>
+              <a:rPr sz="1300" b="1">
+                <a:solidFill>
+                  <a:srgbClr val="000000"/>
+                </a:solidFill>
+              </a:rPr>
+              <a:t>Delivery final como integração por ref()</a:t>
+            </a:r>
           </a:p>
         </p:txBody>
       </p:sp>

</xml_diff>